<commit_message>
Fix LLM Concepts deck — corrected canvas size, eliminated all layout defects
The first commit (2b1b2e0) shipped a deck built on pptxgenjs's default
LAYOUT_16x9 canvas (10"x5.625"), positioned as if there were far more
room. Result: small, sparse-looking diagrams — flagged directly by the
user as poor quality.

Fixed by switching to LAYOUT_WIDE (13.33"x7.5") and rebuilding every
slide's vertical layout with an explicit, computed budget instead of
guessed coordinates. Also caught and fixed a latent bug in the original
slide-3 design (a box position that only avoided overlap by coincidence
of short text) by redesigning it as a horizontal row, consistent with
slides 1-2.

Verified structurally (python-pptx opens cleanly, confirms 13.33x7.5)
and visually — rendered to PDF/JPEG at each iteration and inspected
every slide for boundary/overflow defects before calling it done.

Co-Authored-By: Claude Haiku 4.5 <noreply@anthropic.com>
</commit_message>
<xml_diff>
--- a/LLM-Concepts-Slides-Enhanced.pptx
+++ b/LLM-Concepts-Slides-Enhanced.pptx
@@ -12,8 +12,8 @@
   <p:notesMasterIdLst>
     <p:notesMasterId r:id="rId5"/>
   </p:notesMasterIdLst>
-  <p:sldSz cx="9144000" cy="5143500"/>
-  <p:notesSz cx="5143500" cy="9144000"/>
+  <p:sldSz cx="12192000" cy="6858000"/>
+  <p:notesSz cx="6858000" cy="12192000"/>
   <p:defaultTextStyle>
     <a:lvl1pPr marL="0" algn="l" defTabSz="914400" rtl="0" eaLnBrk="1" latinLnBrk="0" hangingPunct="1">
       <a:defRPr sz="1800" kern="1200">
@@ -1061,8 +1061,8 @@
         </p:nvSpPr>
         <p:spPr>
           <a:xfrm>
-            <a:off x="274320" y="365760"/>
-            <a:ext cx="2743200" cy="365760"/>
+            <a:off x="411480" y="365760"/>
+            <a:ext cx="3566160" cy="548640"/>
           </a:xfrm>
           <a:prstGeom prst="roundRect">
             <a:avLst>
@@ -1088,8 +1088,8 @@
         </p:nvSpPr>
         <p:spPr>
           <a:xfrm>
-            <a:off x="274320" y="365760"/>
-            <a:ext cx="2743200" cy="365760"/>
+            <a:off x="411480" y="365760"/>
+            <a:ext cx="3566160" cy="548640"/>
           </a:xfrm>
           <a:prstGeom prst="rect">
             <a:avLst/>
@@ -1127,24 +1127,24 @@
         </p:nvSpPr>
         <p:spPr>
           <a:xfrm>
-            <a:off x="274320" y="914400"/>
-            <a:ext cx="7315200" cy="548640"/>
-          </a:xfrm>
-          <a:prstGeom prst="rect">
-            <a:avLst/>
-          </a:prstGeom>
-          <a:noFill/>
-          <a:ln/>
-        </p:spPr>
-        <p:txBody>
-          <a:bodyPr wrap="square" rtlCol="0" anchor="ctr"/>
-          <a:lstStyle/>
-          <a:p>
-            <a:pPr indent="0" marL="0">
-              <a:buNone/>
-            </a:pPr>
-            <a:r>
-              <a:rPr lang="en-US" sz="4400" b="1" dirty="0">
+            <a:off x="411480" y="1051560"/>
+            <a:ext cx="11368735" cy="777240"/>
+          </a:xfrm>
+          <a:prstGeom prst="rect">
+            <a:avLst/>
+          </a:prstGeom>
+          <a:noFill/>
+          <a:ln/>
+        </p:spPr>
+        <p:txBody>
+          <a:bodyPr wrap="square" rtlCol="0" anchor="t"/>
+          <a:lstStyle/>
+          <a:p>
+            <a:pPr algn="l" indent="0" marL="0">
+              <a:buNone/>
+            </a:pPr>
+            <a:r>
+              <a:rPr lang="en-US" sz="4200" b="1" dirty="0">
                 <a:solidFill>
                   <a:srgbClr val="FFFFFF"/>
                 </a:solidFill>
@@ -1154,7 +1154,7 @@
               </a:rPr>
               <a:t>How an LLM Works</a:t>
             </a:r>
-            <a:endParaRPr lang="en-US" sz="4400" dirty="0"/>
+            <a:endParaRPr lang="en-US" sz="4200" dirty="0"/>
           </a:p>
         </p:txBody>
       </p:sp>
@@ -1166,8 +1166,8 @@
         </p:nvSpPr>
         <p:spPr>
           <a:xfrm>
-            <a:off x="274320" y="1554480"/>
-            <a:ext cx="7315200" cy="731520"/>
+            <a:off x="411480" y="1920240"/>
+            <a:ext cx="11368735" cy="777240"/>
           </a:xfrm>
           <a:prstGeom prst="rect">
             <a:avLst/>
@@ -1183,7 +1183,7 @@
               <a:buNone/>
             </a:pPr>
             <a:r>
-              <a:rPr lang="en-US" sz="1800" dirty="0">
+              <a:rPr lang="en-US" sz="2200" b="1" dirty="0">
                 <a:solidFill>
                   <a:srgbClr val="C8A84B"/>
                 </a:solidFill>
@@ -1193,7 +1193,7 @@
               </a:rPr>
               <a:t>It isn't thinking — it's predicting the next most likely word, one token at a time.</a:t>
             </a:r>
-            <a:endParaRPr lang="en-US" sz="1800" dirty="0"/>
+            <a:endParaRPr lang="en-US" sz="2200" dirty="0"/>
           </a:p>
         </p:txBody>
       </p:sp>
@@ -1205,25 +1205,59 @@
         </p:nvSpPr>
         <p:spPr>
           <a:xfrm>
-            <a:off x="365760" y="2468880"/>
-            <a:ext cx="7772400" cy="2560320"/>
+            <a:off x="1280160" y="2880360"/>
+            <a:ext cx="9631375" cy="2606040"/>
           </a:xfrm>
           <a:prstGeom prst="roundRect">
             <a:avLst>
-              <a:gd name="adj" fmla="val 5357"/>
+              <a:gd name="adj" fmla="val 5263"/>
             </a:avLst>
           </a:prstGeom>
           <a:solidFill>
             <a:srgbClr val="F6F4EE"/>
           </a:solidFill>
-          <a:ln w="12700">
+          <a:ln w="38100">
             <a:solidFill>
-              <a:srgbClr val="F6F4EE"/>
+              <a:srgbClr val="C8A84B"/>
             </a:solidFill>
             <a:prstDash val="solid"/>
           </a:ln>
           <a:effectLst>
-            <a:outerShdw sx="100000" sy="100000" kx="0" ky="0" algn="bl" rotWithShape="0" blurRad="101600" dist="38100" dir="2700000">
+            <a:outerShdw sx="100000" sy="100000" kx="0" ky="0" algn="bl" rotWithShape="0" blurRad="177800" dist="63500" dir="2700000">
+              <a:srgbClr val="000000">
+                <a:alpha val="45000"/>
+              </a:srgbClr>
+            </a:outerShdw>
+          </a:effectLst>
+        </p:spPr>
+      </p:sp>
+      <p:sp>
+        <p:nvSpPr>
+          <p:cNvPr id="7" name="Shape 5"/>
+          <p:cNvSpPr/>
+          <p:nvPr/>
+        </p:nvSpPr>
+        <p:spPr>
+          <a:xfrm>
+            <a:off x="1679296" y="3383280"/>
+            <a:ext cx="1783080" cy="685800"/>
+          </a:xfrm>
+          <a:prstGeom prst="roundRect">
+            <a:avLst>
+              <a:gd name="adj" fmla="val 13333"/>
+            </a:avLst>
+          </a:prstGeom>
+          <a:solidFill>
+            <a:srgbClr val="2C6B57"/>
+          </a:solidFill>
+          <a:ln w="31750">
+            <a:solidFill>
+              <a:srgbClr val="C8A84B"/>
+            </a:solidFill>
+            <a:prstDash val="solid"/>
+          </a:ln>
+          <a:effectLst>
+            <a:outerShdw sx="100000" sy="100000" kx="0" ky="0" algn="bl" rotWithShape="0" blurRad="63500" dist="25400" dir="2700000">
               <a:srgbClr val="000000">
                 <a:alpha val="30000"/>
               </a:srgbClr>
@@ -1233,14 +1267,14 @@
       </p:sp>
       <p:sp>
         <p:nvSpPr>
-          <p:cNvPr id="7" name="Text 5"/>
-          <p:cNvSpPr/>
-          <p:nvPr/>
-        </p:nvSpPr>
-        <p:spPr>
-          <a:xfrm>
-            <a:off x="548640" y="2743200"/>
-            <a:ext cx="7406640" cy="2011680"/>
+          <p:cNvPr id="8" name="Text 6"/>
+          <p:cNvSpPr/>
+          <p:nvPr/>
+        </p:nvSpPr>
+        <p:spPr>
+          <a:xfrm>
+            <a:off x="1679296" y="3383280"/>
+            <a:ext cx="1783080" cy="685800"/>
           </a:xfrm>
           <a:prstGeom prst="rect">
             <a:avLst/>
@@ -1256,57 +1290,456 @@
               <a:buNone/>
             </a:pPr>
             <a:r>
-              <a:rPr lang="en-US" sz="1600" dirty="0">
-                <a:solidFill>
-                  <a:srgbClr val="1A2422"/>
+              <a:rPr lang="en-US" sz="1300" b="1" dirty="0">
+                <a:solidFill>
+                  <a:srgbClr val="FFFFFF"/>
                 </a:solidFill>
                 <a:latin typeface="Calibri" pitchFamily="34" charset="0"/>
                 <a:ea typeface="Calibri" pitchFamily="34" charset="-122"/>
                 <a:cs typeface="Calibri" pitchFamily="34" charset="-120"/>
               </a:rPr>
-              <a:t>Token Prediction Network</a:t>
-            </a:r>
-            <a:endParaRPr lang="en-US" sz="1600" dirty="0"/>
-          </a:p>
+              <a:t>INPUT</a:t>
+            </a:r>
+            <a:endParaRPr lang="en-US" sz="1300" dirty="0"/>
+          </a:p>
+        </p:txBody>
+      </p:sp>
+      <p:sp>
+        <p:nvSpPr>
+          <p:cNvPr id="9" name="Text 7"/>
+          <p:cNvSpPr/>
+          <p:nvPr/>
+        </p:nvSpPr>
+        <p:spPr>
+          <a:xfrm>
+            <a:off x="3462376" y="3383280"/>
+            <a:ext cx="566928" cy="685800"/>
+          </a:xfrm>
+          <a:prstGeom prst="rect">
+            <a:avLst/>
+          </a:prstGeom>
+          <a:noFill/>
+          <a:ln/>
+        </p:spPr>
+        <p:txBody>
+          <a:bodyPr wrap="square" rtlCol="0" anchor="ctr"/>
+          <a:lstStyle/>
           <a:p>
             <a:pPr algn="ctr" indent="0" marL="0">
               <a:buNone/>
             </a:pPr>
-            <a:endParaRPr lang="en-US" sz="1600" dirty="0"/>
-          </a:p>
+            <a:r>
+              <a:rPr lang="en-US" sz="2600" b="1" dirty="0">
+                <a:solidFill>
+                  <a:srgbClr val="C8A84B"/>
+                </a:solidFill>
+              </a:rPr>
+              <a:t>→</a:t>
+            </a:r>
+            <a:endParaRPr lang="en-US" sz="2600" dirty="0"/>
+          </a:p>
+        </p:txBody>
+      </p:sp>
+      <p:sp>
+        <p:nvSpPr>
+          <p:cNvPr id="10" name="Shape 8"/>
+          <p:cNvSpPr/>
+          <p:nvPr/>
+        </p:nvSpPr>
+        <p:spPr>
+          <a:xfrm>
+            <a:off x="4029304" y="3383280"/>
+            <a:ext cx="1783080" cy="685800"/>
+          </a:xfrm>
+          <a:prstGeom prst="roundRect">
+            <a:avLst>
+              <a:gd name="adj" fmla="val 13333"/>
+            </a:avLst>
+          </a:prstGeom>
+          <a:solidFill>
+            <a:srgbClr val="2C6B57"/>
+          </a:solidFill>
+          <a:ln w="31750">
+            <a:solidFill>
+              <a:srgbClr val="C8A84B"/>
+            </a:solidFill>
+            <a:prstDash val="solid"/>
+          </a:ln>
+          <a:effectLst>
+            <a:outerShdw sx="100000" sy="100000" kx="0" ky="0" algn="bl" rotWithShape="0" blurRad="63500" dist="25400" dir="2700000">
+              <a:srgbClr val="000000">
+                <a:alpha val="30000"/>
+              </a:srgbClr>
+            </a:outerShdw>
+          </a:effectLst>
+        </p:spPr>
+      </p:sp>
+      <p:sp>
+        <p:nvSpPr>
+          <p:cNvPr id="11" name="Text 9"/>
+          <p:cNvSpPr/>
+          <p:nvPr/>
+        </p:nvSpPr>
+        <p:spPr>
+          <a:xfrm>
+            <a:off x="4029304" y="3383280"/>
+            <a:ext cx="1783080" cy="685800"/>
+          </a:xfrm>
+          <a:prstGeom prst="rect">
+            <a:avLst/>
+          </a:prstGeom>
+          <a:noFill/>
+          <a:ln/>
+        </p:spPr>
+        <p:txBody>
+          <a:bodyPr wrap="square" rtlCol="0" anchor="ctr"/>
+          <a:lstStyle/>
           <a:p>
             <a:pPr algn="ctr" indent="0" marL="0">
               <a:buNone/>
             </a:pPr>
             <a:r>
-              <a:rPr lang="en-US" sz="1600" dirty="0">
-                <a:solidFill>
-                  <a:srgbClr val="1A2422"/>
+              <a:rPr lang="en-US" sz="1300" b="1" dirty="0">
+                <a:solidFill>
+                  <a:srgbClr val="FFFFFF"/>
                 </a:solidFill>
                 <a:latin typeface="Calibri" pitchFamily="34" charset="0"/>
                 <a:ea typeface="Calibri" pitchFamily="34" charset="-122"/>
                 <a:cs typeface="Calibri" pitchFamily="34" charset="-120"/>
               </a:rPr>
-              <a:t>● Input → Attention Layers → Output Token</a:t>
-            </a:r>
-            <a:endParaRPr lang="en-US" sz="1600" dirty="0"/>
-          </a:p>
-        </p:txBody>
-      </p:sp>
-      <p:sp>
-        <p:nvSpPr>
-          <p:cNvPr id="8" name="Shape 6"/>
-          <p:cNvSpPr/>
-          <p:nvPr/>
-        </p:nvSpPr>
-        <p:spPr>
-          <a:xfrm>
-            <a:off x="274320" y="5303520"/>
-            <a:ext cx="7955280" cy="457200"/>
+              <a:t>ATTENTION</a:t>
+            </a:r>
+            <a:endParaRPr lang="en-US" sz="1300" dirty="0"/>
+          </a:p>
+        </p:txBody>
+      </p:sp>
+      <p:sp>
+        <p:nvSpPr>
+          <p:cNvPr id="12" name="Text 10"/>
+          <p:cNvSpPr/>
+          <p:nvPr/>
+        </p:nvSpPr>
+        <p:spPr>
+          <a:xfrm>
+            <a:off x="5812384" y="3383280"/>
+            <a:ext cx="566928" cy="685800"/>
+          </a:xfrm>
+          <a:prstGeom prst="rect">
+            <a:avLst/>
+          </a:prstGeom>
+          <a:noFill/>
+          <a:ln/>
+        </p:spPr>
+        <p:txBody>
+          <a:bodyPr wrap="square" rtlCol="0" anchor="ctr"/>
+          <a:lstStyle/>
+          <a:p>
+            <a:pPr algn="ctr" indent="0" marL="0">
+              <a:buNone/>
+            </a:pPr>
+            <a:r>
+              <a:rPr lang="en-US" sz="2600" b="1" dirty="0">
+                <a:solidFill>
+                  <a:srgbClr val="C8A84B"/>
+                </a:solidFill>
+              </a:rPr>
+              <a:t>→</a:t>
+            </a:r>
+            <a:endParaRPr lang="en-US" sz="2600" dirty="0"/>
+          </a:p>
+        </p:txBody>
+      </p:sp>
+      <p:sp>
+        <p:nvSpPr>
+          <p:cNvPr id="13" name="Shape 11"/>
+          <p:cNvSpPr/>
+          <p:nvPr/>
+        </p:nvSpPr>
+        <p:spPr>
+          <a:xfrm>
+            <a:off x="6379312" y="3383280"/>
+            <a:ext cx="1783080" cy="685800"/>
           </a:xfrm>
           <a:prstGeom prst="roundRect">
             <a:avLst>
-              <a:gd name="adj" fmla="val 16000"/>
+              <a:gd name="adj" fmla="val 13333"/>
+            </a:avLst>
+          </a:prstGeom>
+          <a:solidFill>
+            <a:srgbClr val="2C6B57"/>
+          </a:solidFill>
+          <a:ln w="31750">
+            <a:solidFill>
+              <a:srgbClr val="C8A84B"/>
+            </a:solidFill>
+            <a:prstDash val="solid"/>
+          </a:ln>
+          <a:effectLst>
+            <a:outerShdw sx="100000" sy="100000" kx="0" ky="0" algn="bl" rotWithShape="0" blurRad="63500" dist="25400" dir="2700000">
+              <a:srgbClr val="000000">
+                <a:alpha val="30000"/>
+              </a:srgbClr>
+            </a:outerShdw>
+          </a:effectLst>
+        </p:spPr>
+      </p:sp>
+      <p:sp>
+        <p:nvSpPr>
+          <p:cNvPr id="14" name="Text 12"/>
+          <p:cNvSpPr/>
+          <p:nvPr/>
+        </p:nvSpPr>
+        <p:spPr>
+          <a:xfrm>
+            <a:off x="6379312" y="3383280"/>
+            <a:ext cx="1783080" cy="685800"/>
+          </a:xfrm>
+          <a:prstGeom prst="rect">
+            <a:avLst/>
+          </a:prstGeom>
+          <a:noFill/>
+          <a:ln/>
+        </p:spPr>
+        <p:txBody>
+          <a:bodyPr wrap="square" rtlCol="0" anchor="ctr"/>
+          <a:lstStyle/>
+          <a:p>
+            <a:pPr algn="ctr" indent="0" marL="0">
+              <a:buNone/>
+            </a:pPr>
+            <a:r>
+              <a:rPr lang="en-US" sz="1300" b="1" dirty="0">
+                <a:solidFill>
+                  <a:srgbClr val="FFFFFF"/>
+                </a:solidFill>
+                <a:latin typeface="Calibri" pitchFamily="34" charset="0"/>
+                <a:ea typeface="Calibri" pitchFamily="34" charset="-122"/>
+                <a:cs typeface="Calibri" pitchFamily="34" charset="-120"/>
+              </a:rPr>
+              <a:t>PROCESS</a:t>
+            </a:r>
+            <a:endParaRPr lang="en-US" sz="1300" dirty="0"/>
+          </a:p>
+        </p:txBody>
+      </p:sp>
+      <p:sp>
+        <p:nvSpPr>
+          <p:cNvPr id="15" name="Text 13"/>
+          <p:cNvSpPr/>
+          <p:nvPr/>
+        </p:nvSpPr>
+        <p:spPr>
+          <a:xfrm>
+            <a:off x="8162392" y="3383280"/>
+            <a:ext cx="566928" cy="685800"/>
+          </a:xfrm>
+          <a:prstGeom prst="rect">
+            <a:avLst/>
+          </a:prstGeom>
+          <a:noFill/>
+          <a:ln/>
+        </p:spPr>
+        <p:txBody>
+          <a:bodyPr wrap="square" rtlCol="0" anchor="ctr"/>
+          <a:lstStyle/>
+          <a:p>
+            <a:pPr algn="ctr" indent="0" marL="0">
+              <a:buNone/>
+            </a:pPr>
+            <a:r>
+              <a:rPr lang="en-US" sz="2600" b="1" dirty="0">
+                <a:solidFill>
+                  <a:srgbClr val="C8A84B"/>
+                </a:solidFill>
+              </a:rPr>
+              <a:t>→</a:t>
+            </a:r>
+            <a:endParaRPr lang="en-US" sz="2600" dirty="0"/>
+          </a:p>
+        </p:txBody>
+      </p:sp>
+      <p:sp>
+        <p:nvSpPr>
+          <p:cNvPr id="16" name="Shape 14"/>
+          <p:cNvSpPr/>
+          <p:nvPr/>
+        </p:nvSpPr>
+        <p:spPr>
+          <a:xfrm>
+            <a:off x="8729320" y="3383280"/>
+            <a:ext cx="1783080" cy="685800"/>
+          </a:xfrm>
+          <a:prstGeom prst="roundRect">
+            <a:avLst>
+              <a:gd name="adj" fmla="val 13333"/>
+            </a:avLst>
+          </a:prstGeom>
+          <a:solidFill>
+            <a:srgbClr val="2C6B57"/>
+          </a:solidFill>
+          <a:ln w="31750">
+            <a:solidFill>
+              <a:srgbClr val="C8A84B"/>
+            </a:solidFill>
+            <a:prstDash val="solid"/>
+          </a:ln>
+          <a:effectLst>
+            <a:outerShdw sx="100000" sy="100000" kx="0" ky="0" algn="bl" rotWithShape="0" blurRad="63500" dist="25400" dir="2700000">
+              <a:srgbClr val="000000">
+                <a:alpha val="30000"/>
+              </a:srgbClr>
+            </a:outerShdw>
+          </a:effectLst>
+        </p:spPr>
+      </p:sp>
+      <p:sp>
+        <p:nvSpPr>
+          <p:cNvPr id="17" name="Text 15"/>
+          <p:cNvSpPr/>
+          <p:nvPr/>
+        </p:nvSpPr>
+        <p:spPr>
+          <a:xfrm>
+            <a:off x="8729320" y="3383280"/>
+            <a:ext cx="1783080" cy="685800"/>
+          </a:xfrm>
+          <a:prstGeom prst="rect">
+            <a:avLst/>
+          </a:prstGeom>
+          <a:noFill/>
+          <a:ln/>
+        </p:spPr>
+        <p:txBody>
+          <a:bodyPr wrap="square" rtlCol="0" anchor="ctr"/>
+          <a:lstStyle/>
+          <a:p>
+            <a:pPr algn="ctr" indent="0" marL="0">
+              <a:buNone/>
+            </a:pPr>
+            <a:r>
+              <a:rPr lang="en-US" sz="1300" b="1" dirty="0">
+                <a:solidFill>
+                  <a:srgbClr val="FFFFFF"/>
+                </a:solidFill>
+                <a:latin typeface="Calibri" pitchFamily="34" charset="0"/>
+                <a:ea typeface="Calibri" pitchFamily="34" charset="-122"/>
+                <a:cs typeface="Calibri" pitchFamily="34" charset="-120"/>
+              </a:rPr>
+              <a:t>OUTPUT</a:t>
+            </a:r>
+            <a:endParaRPr lang="en-US" sz="1300" dirty="0"/>
+          </a:p>
+          <a:p>
+            <a:pPr algn="ctr" indent="0" marL="0">
+              <a:buNone/>
+            </a:pPr>
+            <a:r>
+              <a:rPr lang="en-US" sz="1300" b="1" dirty="0">
+                <a:solidFill>
+                  <a:srgbClr val="FFFFFF"/>
+                </a:solidFill>
+                <a:latin typeface="Calibri" pitchFamily="34" charset="0"/>
+                <a:ea typeface="Calibri" pitchFamily="34" charset="-122"/>
+                <a:cs typeface="Calibri" pitchFamily="34" charset="-120"/>
+              </a:rPr>
+              <a:t>TOKEN</a:t>
+            </a:r>
+            <a:endParaRPr lang="en-US" sz="1300" dirty="0"/>
+          </a:p>
+        </p:txBody>
+      </p:sp>
+      <p:sp>
+        <p:nvSpPr>
+          <p:cNvPr id="18" name="Text 16"/>
+          <p:cNvSpPr/>
+          <p:nvPr/>
+        </p:nvSpPr>
+        <p:spPr>
+          <a:xfrm>
+            <a:off x="1645920" y="4389120"/>
+            <a:ext cx="8899855" cy="640080"/>
+          </a:xfrm>
+          <a:prstGeom prst="rect">
+            <a:avLst/>
+          </a:prstGeom>
+          <a:noFill/>
+          <a:ln/>
+        </p:spPr>
+        <p:txBody>
+          <a:bodyPr wrap="square" rtlCol="0" anchor="t"/>
+          <a:lstStyle/>
+          <a:p>
+            <a:pPr algn="ctr" indent="0" marL="0">
+              <a:buNone/>
+            </a:pPr>
+            <a:r>
+              <a:rPr lang="en-US" sz="1400" i="1" dirty="0">
+                <a:solidFill>
+                  <a:srgbClr val="1A2422"/>
+                </a:solidFill>
+                <a:latin typeface="Calibri" pitchFamily="34" charset="0"/>
+                <a:ea typeface="Calibri" pitchFamily="34" charset="-122"/>
+                <a:cs typeface="Calibri" pitchFamily="34" charset="-120"/>
+              </a:rPr>
+              <a:t>Each token is generated by scanning everything written so far, then scoring every possible next word.</a:t>
+            </a:r>
+            <a:endParaRPr lang="en-US" sz="1400" dirty="0"/>
+          </a:p>
+        </p:txBody>
+      </p:sp>
+      <p:sp>
+        <p:nvSpPr>
+          <p:cNvPr id="19" name="Text 17"/>
+          <p:cNvSpPr/>
+          <p:nvPr/>
+        </p:nvSpPr>
+        <p:spPr>
+          <a:xfrm>
+            <a:off x="1280160" y="5029200"/>
+            <a:ext cx="9631375" cy="320040"/>
+          </a:xfrm>
+          <a:prstGeom prst="rect">
+            <a:avLst/>
+          </a:prstGeom>
+          <a:noFill/>
+          <a:ln/>
+        </p:spPr>
+        <p:txBody>
+          <a:bodyPr wrap="square" rtlCol="0" anchor="ctr"/>
+          <a:lstStyle/>
+          <a:p>
+            <a:pPr algn="ctr" indent="0" marL="0">
+              <a:buNone/>
+            </a:pPr>
+            <a:r>
+              <a:rPr lang="en-US" sz="1300" b="1" dirty="0">
+                <a:solidFill>
+                  <a:srgbClr val="2C6B57"/>
+                </a:solidFill>
+                <a:latin typeface="Calibri" pitchFamily="34" charset="0"/>
+                <a:ea typeface="Calibri" pitchFamily="34" charset="-122"/>
+                <a:cs typeface="Calibri" pitchFamily="34" charset="-120"/>
+              </a:rPr>
+              <a:t>Token-by-Token Prediction Loop</a:t>
+            </a:r>
+            <a:endParaRPr lang="en-US" sz="1300" dirty="0"/>
+          </a:p>
+        </p:txBody>
+      </p:sp>
+      <p:sp>
+        <p:nvSpPr>
+          <p:cNvPr id="20" name="Shape 18"/>
+          <p:cNvSpPr/>
+          <p:nvPr/>
+        </p:nvSpPr>
+        <p:spPr>
+          <a:xfrm>
+            <a:off x="411480" y="5989320"/>
+            <a:ext cx="11368735" cy="566928"/>
+          </a:xfrm>
+          <a:prstGeom prst="roundRect">
+            <a:avLst>
+              <a:gd name="adj" fmla="val 16129"/>
             </a:avLst>
           </a:prstGeom>
           <a:solidFill>
@@ -1318,18 +1751,25 @@
             </a:solidFill>
             <a:prstDash val="solid"/>
           </a:ln>
-        </p:spPr>
-      </p:sp>
-      <p:sp>
-        <p:nvSpPr>
-          <p:cNvPr id="9" name="Text 7"/>
-          <p:cNvSpPr/>
-          <p:nvPr/>
-        </p:nvSpPr>
-        <p:spPr>
-          <a:xfrm>
-            <a:off x="365760" y="5303520"/>
-            <a:ext cx="1097280" cy="457200"/>
+          <a:effectLst>
+            <a:outerShdw sx="100000" sy="100000" kx="0" ky="0" algn="bl" rotWithShape="0" blurRad="101600" dist="25400" dir="2700000">
+              <a:srgbClr val="000000">
+                <a:alpha val="35000"/>
+              </a:srgbClr>
+            </a:outerShdw>
+          </a:effectLst>
+        </p:spPr>
+      </p:sp>
+      <p:sp>
+        <p:nvSpPr>
+          <p:cNvPr id="21" name="Text 19"/>
+          <p:cNvSpPr/>
+          <p:nvPr/>
+        </p:nvSpPr>
+        <p:spPr>
+          <a:xfrm>
+            <a:off x="594360" y="5989320"/>
+            <a:ext cx="1554480" cy="566928"/>
           </a:xfrm>
           <a:prstGeom prst="rect">
             <a:avLst/>
@@ -1345,7 +1785,7 @@
               <a:buNone/>
             </a:pPr>
             <a:r>
-              <a:rPr lang="en-US" sz="1200" b="1" dirty="0">
+              <a:rPr lang="en-US" sz="1400" b="1" dirty="0">
                 <a:solidFill>
                   <a:srgbClr val="C8A84B"/>
                 </a:solidFill>
@@ -1353,22 +1793,22 @@
                 <a:ea typeface="Calibri" pitchFamily="34" charset="-122"/>
                 <a:cs typeface="Calibri" pitchFamily="34" charset="-120"/>
               </a:rPr>
-              <a:t>TAKEAWAY</a:t>
-            </a:r>
-            <a:endParaRPr lang="en-US" sz="1200" dirty="0"/>
-          </a:p>
-        </p:txBody>
-      </p:sp>
-      <p:sp>
-        <p:nvSpPr>
-          <p:cNvPr id="10" name="Text 8"/>
-          <p:cNvSpPr/>
-          <p:nvPr/>
-        </p:nvSpPr>
-        <p:spPr>
-          <a:xfrm>
-            <a:off x="1554480" y="5303520"/>
-            <a:ext cx="6675120" cy="457200"/>
+              <a:t>TAKEAWAY:</a:t>
+            </a:r>
+            <a:endParaRPr lang="en-US" sz="1400" dirty="0"/>
+          </a:p>
+        </p:txBody>
+      </p:sp>
+      <p:sp>
+        <p:nvSpPr>
+          <p:cNvPr id="22" name="Text 20"/>
+          <p:cNvSpPr/>
+          <p:nvPr/>
+        </p:nvSpPr>
+        <p:spPr>
+          <a:xfrm>
+            <a:off x="2148840" y="5989320"/>
+            <a:ext cx="9448495" cy="566928"/>
           </a:xfrm>
           <a:prstGeom prst="rect">
             <a:avLst/>
@@ -1384,7 +1824,7 @@
               <a:buNone/>
             </a:pPr>
             <a:r>
-              <a:rPr lang="en-US" sz="1100" dirty="0">
+              <a:rPr lang="en-US" sz="1300" b="1" dirty="0">
                 <a:solidFill>
                   <a:srgbClr val="FFFFFF"/>
                 </a:solidFill>
@@ -1392,9 +1832,9 @@
                 <a:ea typeface="Calibri" pitchFamily="34" charset="-122"/>
                 <a:cs typeface="Calibri" pitchFamily="34" charset="-120"/>
               </a:rPr>
-              <a:t>An LLM is a very powerful autocomplete — pattern-matching at massive scale, not reasoning like a human.</a:t>
-            </a:r>
-            <a:endParaRPr lang="en-US" sz="1100" dirty="0"/>
+              <a:t>An LLM is a very powerful autocomplete — pattern-matching at massive scale, one prediction at a time.</a:t>
+            </a:r>
+            <a:endParaRPr lang="en-US" sz="1300" dirty="0"/>
           </a:p>
         </p:txBody>
       </p:sp>
@@ -1438,8 +1878,8 @@
         </p:nvSpPr>
         <p:spPr>
           <a:xfrm>
-            <a:off x="274320" y="365760"/>
-            <a:ext cx="3474720" cy="365760"/>
+            <a:off x="411480" y="365760"/>
+            <a:ext cx="4206240" cy="548640"/>
           </a:xfrm>
           <a:prstGeom prst="roundRect">
             <a:avLst>
@@ -1465,8 +1905,8 @@
         </p:nvSpPr>
         <p:spPr>
           <a:xfrm>
-            <a:off x="274320" y="365760"/>
-            <a:ext cx="3474720" cy="365760"/>
+            <a:off x="411480" y="365760"/>
+            <a:ext cx="4206240" cy="548640"/>
           </a:xfrm>
           <a:prstGeom prst="rect">
             <a:avLst/>
@@ -1482,7 +1922,7 @@
               <a:buNone/>
             </a:pPr>
             <a:r>
-              <a:rPr lang="en-US" sz="1800" b="1" dirty="0">
+              <a:rPr lang="en-US" sz="2000" b="1" dirty="0">
                 <a:solidFill>
                   <a:srgbClr val="1A2422"/>
                 </a:solidFill>
@@ -1492,7 +1932,7 @@
               </a:rPr>
               <a:t>CONCEPT 2 · THE STEERING WHEEL</a:t>
             </a:r>
-            <a:endParaRPr lang="en-US" sz="1800" dirty="0"/>
+            <a:endParaRPr lang="en-US" sz="2000" dirty="0"/>
           </a:p>
         </p:txBody>
       </p:sp>
@@ -1504,24 +1944,24 @@
         </p:nvSpPr>
         <p:spPr>
           <a:xfrm>
-            <a:off x="274320" y="914400"/>
-            <a:ext cx="7315200" cy="548640"/>
-          </a:xfrm>
-          <a:prstGeom prst="rect">
-            <a:avLst/>
-          </a:prstGeom>
-          <a:noFill/>
-          <a:ln/>
-        </p:spPr>
-        <p:txBody>
-          <a:bodyPr wrap="square" rtlCol="0" anchor="ctr"/>
-          <a:lstStyle/>
-          <a:p>
-            <a:pPr indent="0" marL="0">
-              <a:buNone/>
-            </a:pPr>
-            <a:r>
-              <a:rPr lang="en-US" sz="4400" b="1" dirty="0">
+            <a:off x="411480" y="1051560"/>
+            <a:ext cx="11368735" cy="777240"/>
+          </a:xfrm>
+          <a:prstGeom prst="rect">
+            <a:avLst/>
+          </a:prstGeom>
+          <a:noFill/>
+          <a:ln/>
+        </p:spPr>
+        <p:txBody>
+          <a:bodyPr wrap="square" rtlCol="0" anchor="t"/>
+          <a:lstStyle/>
+          <a:p>
+            <a:pPr algn="l" indent="0" marL="0">
+              <a:buNone/>
+            </a:pPr>
+            <a:r>
+              <a:rPr lang="en-US" sz="4200" b="1" dirty="0">
                 <a:solidFill>
                   <a:srgbClr val="FFFFFF"/>
                 </a:solidFill>
@@ -1531,7 +1971,7 @@
               </a:rPr>
               <a:t>How Prompting Works</a:t>
             </a:r>
-            <a:endParaRPr lang="en-US" sz="4400" dirty="0"/>
+            <a:endParaRPr lang="en-US" sz="4200" dirty="0"/>
           </a:p>
         </p:txBody>
       </p:sp>
@@ -1543,8 +1983,8 @@
         </p:nvSpPr>
         <p:spPr>
           <a:xfrm>
-            <a:off x="274320" y="1554480"/>
-            <a:ext cx="7315200" cy="731520"/>
+            <a:off x="411480" y="1920240"/>
+            <a:ext cx="11368735" cy="777240"/>
           </a:xfrm>
           <a:prstGeom prst="rect">
             <a:avLst/>
@@ -1560,7 +2000,7 @@
               <a:buNone/>
             </a:pPr>
             <a:r>
-              <a:rPr lang="en-US" sz="1800" dirty="0">
+              <a:rPr lang="en-US" sz="2200" b="1" dirty="0">
                 <a:solidFill>
                   <a:srgbClr val="C8A84B"/>
                 </a:solidFill>
@@ -1568,9 +2008,9 @@
                 <a:ea typeface="Calibri" pitchFamily="34" charset="-122"/>
                 <a:cs typeface="Calibri" pitchFamily="34" charset="-120"/>
               </a:rPr>
-              <a:t>The same engine, aimed differently — your instructions shape what comes out.</a:t>
-            </a:r>
-            <a:endParaRPr lang="en-US" sz="1800" dirty="0"/>
+              <a:t>The same engine, aimed differently — your instructions shape the output.</a:t>
+            </a:r>
+            <a:endParaRPr lang="en-US" sz="2200" dirty="0"/>
           </a:p>
         </p:txBody>
       </p:sp>
@@ -1582,16 +2022,397 @@
         </p:nvSpPr>
         <p:spPr>
           <a:xfrm>
-            <a:off x="731520" y="2560320"/>
-            <a:ext cx="1645920" cy="731520"/>
+            <a:off x="1615288" y="2880360"/>
+            <a:ext cx="2468880" cy="960120"/>
           </a:xfrm>
           <a:prstGeom prst="roundRect">
             <a:avLst>
-              <a:gd name="adj" fmla="val 12500"/>
+              <a:gd name="adj" fmla="val 13333"/>
             </a:avLst>
           </a:prstGeom>
           <a:solidFill>
             <a:srgbClr val="2C6B57"/>
+          </a:solidFill>
+          <a:ln w="38100">
+            <a:solidFill>
+              <a:srgbClr val="C8A84B"/>
+            </a:solidFill>
+            <a:prstDash val="solid"/>
+          </a:ln>
+          <a:effectLst>
+            <a:outerShdw sx="100000" sy="100000" kx="0" ky="0" algn="bl" rotWithShape="0" blurRad="127000" dist="38100" dir="2700000">
+              <a:srgbClr val="000000">
+                <a:alpha val="40000"/>
+              </a:srgbClr>
+            </a:outerShdw>
+          </a:effectLst>
+        </p:spPr>
+      </p:sp>
+      <p:sp>
+        <p:nvSpPr>
+          <p:cNvPr id="7" name="Text 5"/>
+          <p:cNvSpPr/>
+          <p:nvPr/>
+        </p:nvSpPr>
+        <p:spPr>
+          <a:xfrm>
+            <a:off x="1615288" y="2880360"/>
+            <a:ext cx="2468880" cy="960120"/>
+          </a:xfrm>
+          <a:prstGeom prst="rect">
+            <a:avLst/>
+          </a:prstGeom>
+          <a:noFill/>
+          <a:ln/>
+        </p:spPr>
+        <p:txBody>
+          <a:bodyPr wrap="square" rtlCol="0" anchor="ctr"/>
+          <a:lstStyle/>
+          <a:p>
+            <a:pPr algn="ctr" indent="0" marL="0">
+              <a:buNone/>
+            </a:pPr>
+            <a:r>
+              <a:rPr lang="en-US" sz="1700" b="1" dirty="0">
+                <a:solidFill>
+                  <a:srgbClr val="FFFFFF"/>
+                </a:solidFill>
+                <a:latin typeface="Calibri" pitchFamily="34" charset="0"/>
+                <a:ea typeface="Calibri" pitchFamily="34" charset="-122"/>
+                <a:cs typeface="Calibri" pitchFamily="34" charset="-120"/>
+              </a:rPr>
+              <a:t>PROMPT</a:t>
+            </a:r>
+            <a:endParaRPr lang="en-US" sz="1700" dirty="0"/>
+          </a:p>
+          <a:p>
+            <a:pPr algn="ctr" indent="0" marL="0">
+              <a:buNone/>
+            </a:pPr>
+            <a:r>
+              <a:rPr lang="en-US" sz="1700" b="1" dirty="0">
+                <a:solidFill>
+                  <a:srgbClr val="FFFFFF"/>
+                </a:solidFill>
+                <a:latin typeface="Calibri" pitchFamily="34" charset="0"/>
+                <a:ea typeface="Calibri" pitchFamily="34" charset="-122"/>
+                <a:cs typeface="Calibri" pitchFamily="34" charset="-120"/>
+              </a:rPr>
+              <a:t>"Explain AI"</a:t>
+            </a:r>
+            <a:endParaRPr lang="en-US" sz="1700" dirty="0"/>
+          </a:p>
+        </p:txBody>
+      </p:sp>
+      <p:sp>
+        <p:nvSpPr>
+          <p:cNvPr id="8" name="Text 6"/>
+          <p:cNvSpPr/>
+          <p:nvPr/>
+        </p:nvSpPr>
+        <p:spPr>
+          <a:xfrm>
+            <a:off x="4084168" y="2880360"/>
+            <a:ext cx="777240" cy="960120"/>
+          </a:xfrm>
+          <a:prstGeom prst="rect">
+            <a:avLst/>
+          </a:prstGeom>
+          <a:noFill/>
+          <a:ln/>
+        </p:spPr>
+        <p:txBody>
+          <a:bodyPr wrap="square" rtlCol="0" anchor="ctr"/>
+          <a:lstStyle/>
+          <a:p>
+            <a:pPr algn="ctr" indent="0" marL="0">
+              <a:buNone/>
+            </a:pPr>
+            <a:r>
+              <a:rPr lang="en-US" sz="4000" b="1" dirty="0">
+                <a:solidFill>
+                  <a:srgbClr val="C8A84B"/>
+                </a:solidFill>
+              </a:rPr>
+              <a:t>→</a:t>
+            </a:r>
+            <a:endParaRPr lang="en-US" sz="4000" dirty="0"/>
+          </a:p>
+        </p:txBody>
+      </p:sp>
+      <p:sp>
+        <p:nvSpPr>
+          <p:cNvPr id="9" name="Shape 7"/>
+          <p:cNvSpPr/>
+          <p:nvPr/>
+        </p:nvSpPr>
+        <p:spPr>
+          <a:xfrm>
+            <a:off x="4861408" y="2880360"/>
+            <a:ext cx="2468880" cy="960120"/>
+          </a:xfrm>
+          <a:prstGeom prst="roundRect">
+            <a:avLst>
+              <a:gd name="adj" fmla="val 13333"/>
+            </a:avLst>
+          </a:prstGeom>
+          <a:solidFill>
+            <a:srgbClr val="2C6B57"/>
+          </a:solidFill>
+          <a:ln w="38100">
+            <a:solidFill>
+              <a:srgbClr val="C8A84B"/>
+            </a:solidFill>
+            <a:prstDash val="solid"/>
+          </a:ln>
+          <a:effectLst>
+            <a:outerShdw sx="100000" sy="100000" kx="0" ky="0" algn="bl" rotWithShape="0" blurRad="127000" dist="38100" dir="2700000">
+              <a:srgbClr val="000000">
+                <a:alpha val="40000"/>
+              </a:srgbClr>
+            </a:outerShdw>
+          </a:effectLst>
+        </p:spPr>
+      </p:sp>
+      <p:sp>
+        <p:nvSpPr>
+          <p:cNvPr id="10" name="Text 8"/>
+          <p:cNvSpPr/>
+          <p:nvPr/>
+        </p:nvSpPr>
+        <p:spPr>
+          <a:xfrm>
+            <a:off x="4861408" y="2880360"/>
+            <a:ext cx="2468880" cy="960120"/>
+          </a:xfrm>
+          <a:prstGeom prst="rect">
+            <a:avLst/>
+          </a:prstGeom>
+          <a:noFill/>
+          <a:ln/>
+        </p:spPr>
+        <p:txBody>
+          <a:bodyPr wrap="square" rtlCol="0" anchor="ctr"/>
+          <a:lstStyle/>
+          <a:p>
+            <a:pPr algn="ctr" indent="0" marL="0">
+              <a:buNone/>
+            </a:pPr>
+            <a:r>
+              <a:rPr lang="en-US" sz="1700" b="1" dirty="0">
+                <a:solidFill>
+                  <a:srgbClr val="FFFFFF"/>
+                </a:solidFill>
+                <a:latin typeface="Calibri" pitchFamily="34" charset="0"/>
+                <a:ea typeface="Calibri" pitchFamily="34" charset="-122"/>
+                <a:cs typeface="Calibri" pitchFamily="34" charset="-120"/>
+              </a:rPr>
+              <a:t>LLM</a:t>
+            </a:r>
+            <a:endParaRPr lang="en-US" sz="1700" dirty="0"/>
+          </a:p>
+          <a:p>
+            <a:pPr algn="ctr" indent="0" marL="0">
+              <a:buNone/>
+            </a:pPr>
+            <a:r>
+              <a:rPr lang="en-US" sz="1700" b="1" dirty="0">
+                <a:solidFill>
+                  <a:srgbClr val="FFFFFF"/>
+                </a:solidFill>
+                <a:latin typeface="Calibri" pitchFamily="34" charset="0"/>
+                <a:ea typeface="Calibri" pitchFamily="34" charset="-122"/>
+                <a:cs typeface="Calibri" pitchFamily="34" charset="-120"/>
+              </a:rPr>
+              <a:t>(Same Engine)</a:t>
+            </a:r>
+            <a:endParaRPr lang="en-US" sz="1700" dirty="0"/>
+          </a:p>
+        </p:txBody>
+      </p:sp>
+      <p:sp>
+        <p:nvSpPr>
+          <p:cNvPr id="11" name="Text 9"/>
+          <p:cNvSpPr/>
+          <p:nvPr/>
+        </p:nvSpPr>
+        <p:spPr>
+          <a:xfrm>
+            <a:off x="7330288" y="2880360"/>
+            <a:ext cx="777240" cy="960120"/>
+          </a:xfrm>
+          <a:prstGeom prst="rect">
+            <a:avLst/>
+          </a:prstGeom>
+          <a:noFill/>
+          <a:ln/>
+        </p:spPr>
+        <p:txBody>
+          <a:bodyPr wrap="square" rtlCol="0" anchor="ctr"/>
+          <a:lstStyle/>
+          <a:p>
+            <a:pPr algn="ctr" indent="0" marL="0">
+              <a:buNone/>
+            </a:pPr>
+            <a:r>
+              <a:rPr lang="en-US" sz="4000" b="1" dirty="0">
+                <a:solidFill>
+                  <a:srgbClr val="C8A84B"/>
+                </a:solidFill>
+              </a:rPr>
+              <a:t>→</a:t>
+            </a:r>
+            <a:endParaRPr lang="en-US" sz="4000" dirty="0"/>
+          </a:p>
+        </p:txBody>
+      </p:sp>
+      <p:sp>
+        <p:nvSpPr>
+          <p:cNvPr id="12" name="Shape 10"/>
+          <p:cNvSpPr/>
+          <p:nvPr/>
+        </p:nvSpPr>
+        <p:spPr>
+          <a:xfrm>
+            <a:off x="8107528" y="2880360"/>
+            <a:ext cx="2468880" cy="960120"/>
+          </a:xfrm>
+          <a:prstGeom prst="roundRect">
+            <a:avLst>
+              <a:gd name="adj" fmla="val 13333"/>
+            </a:avLst>
+          </a:prstGeom>
+          <a:solidFill>
+            <a:srgbClr val="2C6B57"/>
+          </a:solidFill>
+          <a:ln w="38100">
+            <a:solidFill>
+              <a:srgbClr val="C8A84B"/>
+            </a:solidFill>
+            <a:prstDash val="solid"/>
+          </a:ln>
+          <a:effectLst>
+            <a:outerShdw sx="100000" sy="100000" kx="0" ky="0" algn="bl" rotWithShape="0" blurRad="127000" dist="38100" dir="2700000">
+              <a:srgbClr val="000000">
+                <a:alpha val="40000"/>
+              </a:srgbClr>
+            </a:outerShdw>
+          </a:effectLst>
+        </p:spPr>
+      </p:sp>
+      <p:sp>
+        <p:nvSpPr>
+          <p:cNvPr id="13" name="Text 11"/>
+          <p:cNvSpPr/>
+          <p:nvPr/>
+        </p:nvSpPr>
+        <p:spPr>
+          <a:xfrm>
+            <a:off x="8107528" y="2880360"/>
+            <a:ext cx="2468880" cy="960120"/>
+          </a:xfrm>
+          <a:prstGeom prst="rect">
+            <a:avLst/>
+          </a:prstGeom>
+          <a:noFill/>
+          <a:ln/>
+        </p:spPr>
+        <p:txBody>
+          <a:bodyPr wrap="square" rtlCol="0" anchor="ctr"/>
+          <a:lstStyle/>
+          <a:p>
+            <a:pPr algn="ctr" indent="0" marL="0">
+              <a:buNone/>
+            </a:pPr>
+            <a:r>
+              <a:rPr lang="en-US" sz="1700" b="1" dirty="0">
+                <a:solidFill>
+                  <a:srgbClr val="FFFFFF"/>
+                </a:solidFill>
+                <a:latin typeface="Calibri" pitchFamily="34" charset="0"/>
+                <a:ea typeface="Calibri" pitchFamily="34" charset="-122"/>
+                <a:cs typeface="Calibri" pitchFamily="34" charset="-120"/>
+              </a:rPr>
+              <a:t>OUTPUT</a:t>
+            </a:r>
+            <a:endParaRPr lang="en-US" sz="1700" dirty="0"/>
+          </a:p>
+          <a:p>
+            <a:pPr algn="ctr" indent="0" marL="0">
+              <a:buNone/>
+            </a:pPr>
+            <a:r>
+              <a:rPr lang="en-US" sz="1700" b="1" dirty="0">
+                <a:solidFill>
+                  <a:srgbClr val="FFFFFF"/>
+                </a:solidFill>
+                <a:latin typeface="Calibri" pitchFamily="34" charset="0"/>
+                <a:ea typeface="Calibri" pitchFamily="34" charset="-122"/>
+                <a:cs typeface="Calibri" pitchFamily="34" charset="-120"/>
+              </a:rPr>
+              <a:t>(Result)</a:t>
+            </a:r>
+            <a:endParaRPr lang="en-US" sz="1700" dirty="0"/>
+          </a:p>
+        </p:txBody>
+      </p:sp>
+      <p:sp>
+        <p:nvSpPr>
+          <p:cNvPr id="14" name="Text 12"/>
+          <p:cNvSpPr/>
+          <p:nvPr/>
+        </p:nvSpPr>
+        <p:spPr>
+          <a:xfrm>
+            <a:off x="411480" y="4160520"/>
+            <a:ext cx="11368735" cy="411480"/>
+          </a:xfrm>
+          <a:prstGeom prst="rect">
+            <a:avLst/>
+          </a:prstGeom>
+          <a:noFill/>
+          <a:ln/>
+        </p:spPr>
+        <p:txBody>
+          <a:bodyPr wrap="square" rtlCol="0" anchor="ctr"/>
+          <a:lstStyle/>
+          <a:p>
+            <a:pPr algn="ctr" indent="0" marL="0">
+              <a:buNone/>
+            </a:pPr>
+            <a:r>
+              <a:rPr lang="en-US" sz="2100" b="1" dirty="0">
+                <a:solidFill>
+                  <a:srgbClr val="C8A84B"/>
+                </a:solidFill>
+                <a:latin typeface="Calibri" pitchFamily="34" charset="0"/>
+                <a:ea typeface="Calibri" pitchFamily="34" charset="-122"/>
+                <a:cs typeface="Calibri" pitchFamily="34" charset="-120"/>
+              </a:rPr>
+              <a:t>Different Prompts = Different Outputs</a:t>
+            </a:r>
+            <a:endParaRPr lang="en-US" sz="2100" dirty="0"/>
+          </a:p>
+        </p:txBody>
+      </p:sp>
+      <p:sp>
+        <p:nvSpPr>
+          <p:cNvPr id="15" name="Shape 13"/>
+          <p:cNvSpPr/>
+          <p:nvPr/>
+        </p:nvSpPr>
+        <p:spPr>
+          <a:xfrm>
+            <a:off x="1066648" y="4663440"/>
+            <a:ext cx="3017520" cy="960120"/>
+          </a:xfrm>
+          <a:prstGeom prst="roundRect">
+            <a:avLst>
+              <a:gd name="adj" fmla="val 9524"/>
+            </a:avLst>
+          </a:prstGeom>
+          <a:solidFill>
+            <a:srgbClr val="F6F4EE"/>
           </a:solidFill>
           <a:ln w="25400">
             <a:solidFill>
@@ -1599,18 +2420,25 @@
             </a:solidFill>
             <a:prstDash val="solid"/>
           </a:ln>
-        </p:spPr>
-      </p:sp>
-      <p:sp>
-        <p:nvSpPr>
-          <p:cNvPr id="7" name="Text 5"/>
-          <p:cNvSpPr/>
-          <p:nvPr/>
-        </p:nvSpPr>
-        <p:spPr>
-          <a:xfrm>
-            <a:off x="731520" y="2560320"/>
-            <a:ext cx="1645920" cy="731520"/>
+          <a:effectLst>
+            <a:outerShdw sx="100000" sy="100000" kx="0" ky="0" algn="bl" rotWithShape="0" blurRad="76200" dist="25400" dir="2700000">
+              <a:srgbClr val="000000">
+                <a:alpha val="25000"/>
+              </a:srgbClr>
+            </a:outerShdw>
+          </a:effectLst>
+        </p:spPr>
+      </p:sp>
+      <p:sp>
+        <p:nvSpPr>
+          <p:cNvPr id="16" name="Text 14"/>
+          <p:cNvSpPr/>
+          <p:nvPr/>
+        </p:nvSpPr>
+        <p:spPr>
+          <a:xfrm>
+            <a:off x="1158088" y="4736592"/>
+            <a:ext cx="2834640" cy="457200"/>
           </a:xfrm>
           <a:prstGeom prst="rect">
             <a:avLst/>
@@ -1628,13 +2456,13 @@
             <a:r>
               <a:rPr lang="en-US" sz="1400" b="1" dirty="0">
                 <a:solidFill>
-                  <a:srgbClr val="FFFFFF"/>
+                  <a:srgbClr val="1A2422"/>
                 </a:solidFill>
                 <a:latin typeface="Calibri" pitchFamily="34" charset="0"/>
                 <a:ea typeface="Calibri" pitchFamily="34" charset="-122"/>
                 <a:cs typeface="Calibri" pitchFamily="34" charset="-120"/>
               </a:rPr>
-              <a:t>Prompt</a:t>
+              <a:t>"Write a poem"</a:t>
             </a:r>
             <a:endParaRPr lang="en-US" sz="1400" dirty="0"/>
           </a:p>
@@ -1642,22 +2470,61 @@
       </p:sp>
       <p:sp>
         <p:nvSpPr>
-          <p:cNvPr id="8" name="Shape 6"/>
-          <p:cNvSpPr/>
-          <p:nvPr/>
-        </p:nvSpPr>
-        <p:spPr>
-          <a:xfrm>
-            <a:off x="3749040" y="2560320"/>
-            <a:ext cx="1645920" cy="731520"/>
+          <p:cNvPr id="17" name="Text 15"/>
+          <p:cNvSpPr/>
+          <p:nvPr/>
+        </p:nvSpPr>
+        <p:spPr>
+          <a:xfrm>
+            <a:off x="1158088" y="5166360"/>
+            <a:ext cx="2834640" cy="384048"/>
+          </a:xfrm>
+          <a:prstGeom prst="rect">
+            <a:avLst/>
+          </a:prstGeom>
+          <a:noFill/>
+          <a:ln/>
+        </p:spPr>
+        <p:txBody>
+          <a:bodyPr wrap="square" rtlCol="0" anchor="ctr"/>
+          <a:lstStyle/>
+          <a:p>
+            <a:pPr algn="ctr" indent="0" marL="0">
+              <a:buNone/>
+            </a:pPr>
+            <a:r>
+              <a:rPr lang="en-US" sz="1300" i="1" dirty="0">
+                <a:solidFill>
+                  <a:srgbClr val="2C6B57"/>
+                </a:solidFill>
+                <a:latin typeface="Calibri" pitchFamily="34" charset="0"/>
+                <a:ea typeface="Calibri" pitchFamily="34" charset="-122"/>
+                <a:cs typeface="Calibri" pitchFamily="34" charset="-120"/>
+              </a:rPr>
+              <a:t>Creative text</a:t>
+            </a:r>
+            <a:endParaRPr lang="en-US" sz="1300" dirty="0"/>
+          </a:p>
+        </p:txBody>
+      </p:sp>
+      <p:sp>
+        <p:nvSpPr>
+          <p:cNvPr id="18" name="Shape 16"/>
+          <p:cNvSpPr/>
+          <p:nvPr/>
+        </p:nvSpPr>
+        <p:spPr>
+          <a:xfrm>
+            <a:off x="4587088" y="4663440"/>
+            <a:ext cx="3017520" cy="960120"/>
           </a:xfrm>
           <a:prstGeom prst="roundRect">
             <a:avLst>
-              <a:gd name="adj" fmla="val 12500"/>
+              <a:gd name="adj" fmla="val 9524"/>
             </a:avLst>
           </a:prstGeom>
           <a:solidFill>
-            <a:srgbClr val="2C6B57"/>
+            <a:srgbClr val="F6F4EE"/>
           </a:solidFill>
           <a:ln w="25400">
             <a:solidFill>
@@ -1665,18 +2532,25 @@
             </a:solidFill>
             <a:prstDash val="solid"/>
           </a:ln>
-        </p:spPr>
-      </p:sp>
-      <p:sp>
-        <p:nvSpPr>
-          <p:cNvPr id="9" name="Text 7"/>
-          <p:cNvSpPr/>
-          <p:nvPr/>
-        </p:nvSpPr>
-        <p:spPr>
-          <a:xfrm>
-            <a:off x="3749040" y="2560320"/>
-            <a:ext cx="1645920" cy="731520"/>
+          <a:effectLst>
+            <a:outerShdw sx="100000" sy="100000" kx="0" ky="0" algn="bl" rotWithShape="0" blurRad="76200" dist="25400" dir="2700000">
+              <a:srgbClr val="000000">
+                <a:alpha val="25000"/>
+              </a:srgbClr>
+            </a:outerShdw>
+          </a:effectLst>
+        </p:spPr>
+      </p:sp>
+      <p:sp>
+        <p:nvSpPr>
+          <p:cNvPr id="19" name="Text 17"/>
+          <p:cNvSpPr/>
+          <p:nvPr/>
+        </p:nvSpPr>
+        <p:spPr>
+          <a:xfrm>
+            <a:off x="4678528" y="4736592"/>
+            <a:ext cx="2834640" cy="457200"/>
           </a:xfrm>
           <a:prstGeom prst="rect">
             <a:avLst/>
@@ -1694,13 +2568,13 @@
             <a:r>
               <a:rPr lang="en-US" sz="1400" b="1" dirty="0">
                 <a:solidFill>
-                  <a:srgbClr val="FFFFFF"/>
+                  <a:srgbClr val="1A2422"/>
                 </a:solidFill>
                 <a:latin typeface="Calibri" pitchFamily="34" charset="0"/>
                 <a:ea typeface="Calibri" pitchFamily="34" charset="-122"/>
                 <a:cs typeface="Calibri" pitchFamily="34" charset="-120"/>
               </a:rPr>
-              <a:t>LLM</a:t>
+              <a:t>"Summarize this"</a:t>
             </a:r>
             <a:endParaRPr lang="en-US" sz="1400" dirty="0"/>
           </a:p>
@@ -1708,22 +2582,61 @@
       </p:sp>
       <p:sp>
         <p:nvSpPr>
-          <p:cNvPr id="10" name="Shape 8"/>
-          <p:cNvSpPr/>
-          <p:nvPr/>
-        </p:nvSpPr>
-        <p:spPr>
-          <a:xfrm>
-            <a:off x="6766560" y="2560320"/>
-            <a:ext cx="1645920" cy="731520"/>
+          <p:cNvPr id="20" name="Text 18"/>
+          <p:cNvSpPr/>
+          <p:nvPr/>
+        </p:nvSpPr>
+        <p:spPr>
+          <a:xfrm>
+            <a:off x="4678528" y="5166360"/>
+            <a:ext cx="2834640" cy="384048"/>
+          </a:xfrm>
+          <a:prstGeom prst="rect">
+            <a:avLst/>
+          </a:prstGeom>
+          <a:noFill/>
+          <a:ln/>
+        </p:spPr>
+        <p:txBody>
+          <a:bodyPr wrap="square" rtlCol="0" anchor="ctr"/>
+          <a:lstStyle/>
+          <a:p>
+            <a:pPr algn="ctr" indent="0" marL="0">
+              <a:buNone/>
+            </a:pPr>
+            <a:r>
+              <a:rPr lang="en-US" sz="1300" i="1" dirty="0">
+                <a:solidFill>
+                  <a:srgbClr val="2C6B57"/>
+                </a:solidFill>
+                <a:latin typeface="Calibri" pitchFamily="34" charset="0"/>
+                <a:ea typeface="Calibri" pitchFamily="34" charset="-122"/>
+                <a:cs typeface="Calibri" pitchFamily="34" charset="-120"/>
+              </a:rPr>
+              <a:t>Concise facts</a:t>
+            </a:r>
+            <a:endParaRPr lang="en-US" sz="1300" dirty="0"/>
+          </a:p>
+        </p:txBody>
+      </p:sp>
+      <p:sp>
+        <p:nvSpPr>
+          <p:cNvPr id="21" name="Shape 19"/>
+          <p:cNvSpPr/>
+          <p:nvPr/>
+        </p:nvSpPr>
+        <p:spPr>
+          <a:xfrm>
+            <a:off x="8107528" y="4663440"/>
+            <a:ext cx="3017520" cy="960120"/>
           </a:xfrm>
           <a:prstGeom prst="roundRect">
             <a:avLst>
-              <a:gd name="adj" fmla="val 12500"/>
+              <a:gd name="adj" fmla="val 9524"/>
             </a:avLst>
           </a:prstGeom>
           <a:solidFill>
-            <a:srgbClr val="2C6B57"/>
+            <a:srgbClr val="F6F4EE"/>
           </a:solidFill>
           <a:ln w="25400">
             <a:solidFill>
@@ -1731,18 +2644,25 @@
             </a:solidFill>
             <a:prstDash val="solid"/>
           </a:ln>
-        </p:spPr>
-      </p:sp>
-      <p:sp>
-        <p:nvSpPr>
-          <p:cNvPr id="11" name="Text 9"/>
-          <p:cNvSpPr/>
-          <p:nvPr/>
-        </p:nvSpPr>
-        <p:spPr>
-          <a:xfrm>
-            <a:off x="6766560" y="2560320"/>
-            <a:ext cx="1645920" cy="731520"/>
+          <a:effectLst>
+            <a:outerShdw sx="100000" sy="100000" kx="0" ky="0" algn="bl" rotWithShape="0" blurRad="76200" dist="25400" dir="2700000">
+              <a:srgbClr val="000000">
+                <a:alpha val="25000"/>
+              </a:srgbClr>
+            </a:outerShdw>
+          </a:effectLst>
+        </p:spPr>
+      </p:sp>
+      <p:sp>
+        <p:nvSpPr>
+          <p:cNvPr id="22" name="Text 20"/>
+          <p:cNvSpPr/>
+          <p:nvPr/>
+        </p:nvSpPr>
+        <p:spPr>
+          <a:xfrm>
+            <a:off x="8198968" y="4736592"/>
+            <a:ext cx="2834640" cy="457200"/>
           </a:xfrm>
           <a:prstGeom prst="rect">
             <a:avLst/>
@@ -1760,13 +2680,13 @@
             <a:r>
               <a:rPr lang="en-US" sz="1400" b="1" dirty="0">
                 <a:solidFill>
-                  <a:srgbClr val="FFFFFF"/>
+                  <a:srgbClr val="1A2422"/>
                 </a:solidFill>
                 <a:latin typeface="Calibri" pitchFamily="34" charset="0"/>
                 <a:ea typeface="Calibri" pitchFamily="34" charset="-122"/>
                 <a:cs typeface="Calibri" pitchFamily="34" charset="-120"/>
               </a:rPr>
-              <a:t>Output</a:t>
+              <a:t>"Explain clearly"</a:t>
             </a:r>
             <a:endParaRPr lang="en-US" sz="1400" dirty="0"/>
           </a:p>
@@ -1774,14 +2694,14 @@
       </p:sp>
       <p:sp>
         <p:nvSpPr>
-          <p:cNvPr id="12" name="Text 10"/>
-          <p:cNvSpPr/>
-          <p:nvPr/>
-        </p:nvSpPr>
-        <p:spPr>
-          <a:xfrm>
-            <a:off x="2560320" y="2697480"/>
-            <a:ext cx="6858000" cy="0"/>
+          <p:cNvPr id="23" name="Text 21"/>
+          <p:cNvSpPr/>
+          <p:nvPr/>
+        </p:nvSpPr>
+        <p:spPr>
+          <a:xfrm>
+            <a:off x="8198968" y="5166360"/>
+            <a:ext cx="2834640" cy="384048"/>
           </a:xfrm>
           <a:prstGeom prst="rect">
             <a:avLst/>
@@ -1793,110 +2713,38 @@
           <a:bodyPr wrap="square" rtlCol="0" anchor="ctr"/>
           <a:lstStyle/>
           <a:p>
-            <a:pPr indent="0" marL="0">
-              <a:buNone/>
-            </a:pPr>
-            <a:r>
-              <a:rPr lang="en-US" sz="2400" dirty="0">
-                <a:solidFill>
-                  <a:srgbClr val="C8A84B"/>
-                </a:solidFill>
-              </a:rPr>
-              <a:t>→</a:t>
-            </a:r>
-            <a:endParaRPr lang="en-US" sz="2400" dirty="0"/>
-          </a:p>
-        </p:txBody>
-      </p:sp>
-      <p:sp>
-        <p:nvSpPr>
-          <p:cNvPr id="13" name="Text 11"/>
-          <p:cNvSpPr/>
-          <p:nvPr/>
-        </p:nvSpPr>
-        <p:spPr>
-          <a:xfrm>
-            <a:off x="5577840" y="2697480"/>
-            <a:ext cx="6858000" cy="0"/>
-          </a:xfrm>
-          <a:prstGeom prst="rect">
-            <a:avLst/>
-          </a:prstGeom>
-          <a:noFill/>
-          <a:ln/>
-        </p:spPr>
-        <p:txBody>
-          <a:bodyPr wrap="square" rtlCol="0" anchor="ctr"/>
-          <a:lstStyle/>
-          <a:p>
-            <a:pPr indent="0" marL="0">
-              <a:buNone/>
-            </a:pPr>
-            <a:r>
-              <a:rPr lang="en-US" sz="2400" dirty="0">
-                <a:solidFill>
-                  <a:srgbClr val="C8A84B"/>
-                </a:solidFill>
-              </a:rPr>
-              <a:t>→</a:t>
-            </a:r>
-            <a:endParaRPr lang="en-US" sz="2400" dirty="0"/>
-          </a:p>
-        </p:txBody>
-      </p:sp>
-      <p:sp>
-        <p:nvSpPr>
-          <p:cNvPr id="14" name="Text 12"/>
-          <p:cNvSpPr/>
-          <p:nvPr/>
-        </p:nvSpPr>
-        <p:spPr>
-          <a:xfrm>
-            <a:off x="274320" y="3657600"/>
-            <a:ext cx="7955280" cy="457200"/>
-          </a:xfrm>
-          <a:prstGeom prst="rect">
-            <a:avLst/>
-          </a:prstGeom>
-          <a:noFill/>
-          <a:ln/>
-        </p:spPr>
-        <p:txBody>
-          <a:bodyPr wrap="square" rtlCol="0" anchor="ctr"/>
-          <a:lstStyle/>
-          <a:p>
             <a:pPr algn="ctr" indent="0" marL="0">
               <a:buNone/>
             </a:pPr>
             <a:r>
-              <a:rPr lang="en-US" sz="1600" b="1" dirty="0">
-                <a:solidFill>
-                  <a:srgbClr val="C8A84B"/>
+              <a:rPr lang="en-US" sz="1300" i="1" dirty="0">
+                <a:solidFill>
+                  <a:srgbClr val="2C6B57"/>
                 </a:solidFill>
                 <a:latin typeface="Calibri" pitchFamily="34" charset="0"/>
                 <a:ea typeface="Calibri" pitchFamily="34" charset="-122"/>
                 <a:cs typeface="Calibri" pitchFamily="34" charset="-120"/>
               </a:rPr>
-              <a:t>Different Prompt = Different Output</a:t>
-            </a:r>
-            <a:endParaRPr lang="en-US" sz="1600" dirty="0"/>
-          </a:p>
-        </p:txBody>
-      </p:sp>
-      <p:sp>
-        <p:nvSpPr>
-          <p:cNvPr id="15" name="Shape 13"/>
-          <p:cNvSpPr/>
-          <p:nvPr/>
-        </p:nvSpPr>
-        <p:spPr>
-          <a:xfrm>
-            <a:off x="274320" y="5303520"/>
-            <a:ext cx="7955280" cy="457200"/>
+              <a:t>Detailed breakdown</a:t>
+            </a:r>
+            <a:endParaRPr lang="en-US" sz="1300" dirty="0"/>
+          </a:p>
+        </p:txBody>
+      </p:sp>
+      <p:sp>
+        <p:nvSpPr>
+          <p:cNvPr id="24" name="Shape 22"/>
+          <p:cNvSpPr/>
+          <p:nvPr/>
+        </p:nvSpPr>
+        <p:spPr>
+          <a:xfrm>
+            <a:off x="411480" y="5989320"/>
+            <a:ext cx="11368735" cy="566928"/>
           </a:xfrm>
           <a:prstGeom prst="roundRect">
             <a:avLst>
-              <a:gd name="adj" fmla="val 16000"/>
+              <a:gd name="adj" fmla="val 16129"/>
             </a:avLst>
           </a:prstGeom>
           <a:solidFill>
@@ -1908,18 +2756,25 @@
             </a:solidFill>
             <a:prstDash val="solid"/>
           </a:ln>
-        </p:spPr>
-      </p:sp>
-      <p:sp>
-        <p:nvSpPr>
-          <p:cNvPr id="16" name="Text 14"/>
-          <p:cNvSpPr/>
-          <p:nvPr/>
-        </p:nvSpPr>
-        <p:spPr>
-          <a:xfrm>
-            <a:off x="365760" y="5303520"/>
-            <a:ext cx="1097280" cy="457200"/>
+          <a:effectLst>
+            <a:outerShdw sx="100000" sy="100000" kx="0" ky="0" algn="bl" rotWithShape="0" blurRad="101600" dist="25400" dir="2700000">
+              <a:srgbClr val="000000">
+                <a:alpha val="35000"/>
+              </a:srgbClr>
+            </a:outerShdw>
+          </a:effectLst>
+        </p:spPr>
+      </p:sp>
+      <p:sp>
+        <p:nvSpPr>
+          <p:cNvPr id="25" name="Text 23"/>
+          <p:cNvSpPr/>
+          <p:nvPr/>
+        </p:nvSpPr>
+        <p:spPr>
+          <a:xfrm>
+            <a:off x="594360" y="5989320"/>
+            <a:ext cx="1554480" cy="566928"/>
           </a:xfrm>
           <a:prstGeom prst="rect">
             <a:avLst/>
@@ -1935,7 +2790,7 @@
               <a:buNone/>
             </a:pPr>
             <a:r>
-              <a:rPr lang="en-US" sz="1200" b="1" dirty="0">
+              <a:rPr lang="en-US" sz="1400" b="1" dirty="0">
                 <a:solidFill>
                   <a:srgbClr val="C8A84B"/>
                 </a:solidFill>
@@ -1943,22 +2798,22 @@
                 <a:ea typeface="Calibri" pitchFamily="34" charset="-122"/>
                 <a:cs typeface="Calibri" pitchFamily="34" charset="-120"/>
               </a:rPr>
-              <a:t>TAKEAWAY</a:t>
-            </a:r>
-            <a:endParaRPr lang="en-US" sz="1200" dirty="0"/>
-          </a:p>
-        </p:txBody>
-      </p:sp>
-      <p:sp>
-        <p:nvSpPr>
-          <p:cNvPr id="17" name="Text 15"/>
-          <p:cNvSpPr/>
-          <p:nvPr/>
-        </p:nvSpPr>
-        <p:spPr>
-          <a:xfrm>
-            <a:off x="1554480" y="5303520"/>
-            <a:ext cx="6675120" cy="457200"/>
+              <a:t>TAKEAWAY:</a:t>
+            </a:r>
+            <a:endParaRPr lang="en-US" sz="1400" dirty="0"/>
+          </a:p>
+        </p:txBody>
+      </p:sp>
+      <p:sp>
+        <p:nvSpPr>
+          <p:cNvPr id="26" name="Text 24"/>
+          <p:cNvSpPr/>
+          <p:nvPr/>
+        </p:nvSpPr>
+        <p:spPr>
+          <a:xfrm>
+            <a:off x="2148840" y="5989320"/>
+            <a:ext cx="9448495" cy="566928"/>
           </a:xfrm>
           <a:prstGeom prst="rect">
             <a:avLst/>
@@ -1974,7 +2829,7 @@
               <a:buNone/>
             </a:pPr>
             <a:r>
-              <a:rPr lang="en-US" sz="1100" dirty="0">
+              <a:rPr lang="en-US" sz="1300" b="1" dirty="0">
                 <a:solidFill>
                   <a:srgbClr val="FFFFFF"/>
                 </a:solidFill>
@@ -1982,9 +2837,9 @@
                 <a:ea typeface="Calibri" pitchFamily="34" charset="-122"/>
                 <a:cs typeface="Calibri" pitchFamily="34" charset="-120"/>
               </a:rPr>
-              <a:t>Better prompts don't make the model smarter — they make your intent clearer.</a:t>
-            </a:r>
-            <a:endParaRPr lang="en-US" sz="1100" dirty="0"/>
+              <a:t>Better prompts don't make the model smarter — they make your intent crystal clear to the engine.</a:t>
+            </a:r>
+            <a:endParaRPr lang="en-US" sz="1300" dirty="0"/>
           </a:p>
         </p:txBody>
       </p:sp>
@@ -2028,8 +2883,8 @@
         </p:nvSpPr>
         <p:spPr>
           <a:xfrm>
-            <a:off x="274320" y="365760"/>
-            <a:ext cx="2926080" cy="365760"/>
+            <a:off x="411480" y="365760"/>
+            <a:ext cx="3749040" cy="548640"/>
           </a:xfrm>
           <a:prstGeom prst="roundRect">
             <a:avLst>
@@ -2055,8 +2910,8 @@
         </p:nvSpPr>
         <p:spPr>
           <a:xfrm>
-            <a:off x="274320" y="365760"/>
-            <a:ext cx="2926080" cy="365760"/>
+            <a:off x="411480" y="365760"/>
+            <a:ext cx="3749040" cy="548640"/>
           </a:xfrm>
           <a:prstGeom prst="rect">
             <a:avLst/>
@@ -2072,7 +2927,7 @@
               <a:buNone/>
             </a:pPr>
             <a:r>
-              <a:rPr lang="en-US" sz="1800" b="1" dirty="0">
+              <a:rPr lang="en-US" sz="2000" b="1" dirty="0">
                 <a:solidFill>
                   <a:srgbClr val="1A2422"/>
                 </a:solidFill>
@@ -2082,7 +2937,7 @@
               </a:rPr>
               <a:t>CONCEPT 3 · THE AUTOPILOT</a:t>
             </a:r>
-            <a:endParaRPr lang="en-US" sz="1800" dirty="0"/>
+            <a:endParaRPr lang="en-US" sz="2000" dirty="0"/>
           </a:p>
         </p:txBody>
       </p:sp>
@@ -2094,24 +2949,24 @@
         </p:nvSpPr>
         <p:spPr>
           <a:xfrm>
-            <a:off x="274320" y="914400"/>
-            <a:ext cx="7315200" cy="548640"/>
-          </a:xfrm>
-          <a:prstGeom prst="rect">
-            <a:avLst/>
-          </a:prstGeom>
-          <a:noFill/>
-          <a:ln/>
-        </p:spPr>
-        <p:txBody>
-          <a:bodyPr wrap="square" rtlCol="0" anchor="ctr"/>
-          <a:lstStyle/>
-          <a:p>
-            <a:pPr indent="0" marL="0">
-              <a:buNone/>
-            </a:pPr>
-            <a:r>
-              <a:rPr lang="en-US" sz="4400" b="1" dirty="0">
+            <a:off x="411480" y="1051560"/>
+            <a:ext cx="11368735" cy="777240"/>
+          </a:xfrm>
+          <a:prstGeom prst="rect">
+            <a:avLst/>
+          </a:prstGeom>
+          <a:noFill/>
+          <a:ln/>
+        </p:spPr>
+        <p:txBody>
+          <a:bodyPr wrap="square" rtlCol="0" anchor="t"/>
+          <a:lstStyle/>
+          <a:p>
+            <a:pPr algn="l" indent="0" marL="0">
+              <a:buNone/>
+            </a:pPr>
+            <a:r>
+              <a:rPr lang="en-US" sz="4200" b="1" dirty="0">
                 <a:solidFill>
                   <a:srgbClr val="FFFFFF"/>
                 </a:solidFill>
@@ -2121,7 +2976,7 @@
               </a:rPr>
               <a:t>How Loops &amp; Agents Work</a:t>
             </a:r>
-            <a:endParaRPr lang="en-US" sz="4400" dirty="0"/>
+            <a:endParaRPr lang="en-US" sz="4200" dirty="0"/>
           </a:p>
         </p:txBody>
       </p:sp>
@@ -2133,8 +2988,8 @@
         </p:nvSpPr>
         <p:spPr>
           <a:xfrm>
-            <a:off x="274320" y="1554480"/>
-            <a:ext cx="7315200" cy="731520"/>
+            <a:off x="411480" y="1920240"/>
+            <a:ext cx="11368735" cy="777240"/>
           </a:xfrm>
           <a:prstGeom prst="rect">
             <a:avLst/>
@@ -2150,7 +3005,7 @@
               <a:buNone/>
             </a:pPr>
             <a:r>
-              <a:rPr lang="en-US" sz="1800" dirty="0">
+              <a:rPr lang="en-US" sz="2200" b="1" dirty="0">
                 <a:solidFill>
                   <a:srgbClr val="C8A84B"/>
                 </a:solidFill>
@@ -2158,9 +3013,9 @@
                 <a:ea typeface="Calibri" pitchFamily="34" charset="-122"/>
                 <a:cs typeface="Calibri" pitchFamily="34" charset="-120"/>
               </a:rPr>
-              <a:t>An agent is an LLM given a loop, a goal, and tools — it keeps working until it's done.</a:t>
-            </a:r>
-            <a:endParaRPr lang="en-US" sz="1800" dirty="0"/>
+              <a:t>An agent is an LLM given a loop, a goal, and tools — it keeps working until done.</a:t>
+            </a:r>
+            <a:endParaRPr lang="en-US" sz="2200" dirty="0"/>
           </a:p>
         </p:txBody>
       </p:sp>
@@ -2172,14 +3027,16 @@
         </p:nvSpPr>
         <p:spPr>
           <a:xfrm>
-            <a:off x="3749040" y="2560320"/>
-            <a:ext cx="731520" cy="731520"/>
-          </a:xfrm>
-          <a:prstGeom prst="ellipse">
-            <a:avLst/>
-          </a:prstGeom>
-          <a:solidFill>
-            <a:srgbClr val="F6F4EE"/>
+            <a:off x="2735428" y="3131820"/>
+            <a:ext cx="1965960" cy="914400"/>
+          </a:xfrm>
+          <a:prstGeom prst="roundRect">
+            <a:avLst>
+              <a:gd name="adj" fmla="val 14000"/>
+            </a:avLst>
+          </a:prstGeom>
+          <a:solidFill>
+            <a:srgbClr val="2C6B57"/>
           </a:solidFill>
           <a:ln w="38100">
             <a:solidFill>
@@ -2187,6 +3044,13 @@
             </a:solidFill>
             <a:prstDash val="solid"/>
           </a:ln>
+          <a:effectLst>
+            <a:outerShdw sx="100000" sy="100000" kx="0" ky="0" algn="bl" rotWithShape="0" blurRad="101600" dist="38100" dir="2700000">
+              <a:srgbClr val="000000">
+                <a:alpha val="35000"/>
+              </a:srgbClr>
+            </a:outerShdw>
+          </a:effectLst>
         </p:spPr>
       </p:sp>
       <p:sp>
@@ -2197,8 +3061,8 @@
         </p:nvSpPr>
         <p:spPr>
           <a:xfrm>
-            <a:off x="3749040" y="2560320"/>
-            <a:ext cx="731520" cy="731520"/>
+            <a:off x="2735428" y="3131820"/>
+            <a:ext cx="1965960" cy="914400"/>
           </a:xfrm>
           <a:prstGeom prst="rect">
             <a:avLst/>
@@ -2214,57 +3078,115 @@
               <a:buNone/>
             </a:pPr>
             <a:r>
-              <a:rPr lang="en-US" sz="1400" b="1" dirty="0">
-                <a:solidFill>
-                  <a:srgbClr val="C8A84B"/>
+              <a:rPr lang="en-US" sz="1500" b="1" dirty="0">
+                <a:solidFill>
+                  <a:srgbClr val="FFFFFF"/>
                 </a:solidFill>
                 <a:latin typeface="Calibri" pitchFamily="34" charset="0"/>
                 <a:ea typeface="Calibri" pitchFamily="34" charset="-122"/>
                 <a:cs typeface="Calibri" pitchFamily="34" charset="-120"/>
               </a:rPr>
-              <a:t>LLM</a:t>
-            </a:r>
-            <a:endParaRPr lang="en-US" sz="1400" dirty="0"/>
-          </a:p>
-        </p:txBody>
-      </p:sp>
-      <p:sp>
-        <p:nvSpPr>
-          <p:cNvPr id="8" name="Shape 6"/>
-          <p:cNvSpPr/>
-          <p:nvPr/>
-        </p:nvSpPr>
-        <p:spPr>
-          <a:xfrm>
-            <a:off x="3200400" y="1828800"/>
-            <a:ext cx="914400" cy="457200"/>
-          </a:xfrm>
-          <a:prstGeom prst="roundRect">
-            <a:avLst>
-              <a:gd name="adj" fmla="val 16000"/>
-            </a:avLst>
-          </a:prstGeom>
-          <a:solidFill>
-            <a:srgbClr val="2C6B57"/>
-          </a:solidFill>
-          <a:ln w="19050">
+              <a:t>GOAL</a:t>
+            </a:r>
+            <a:endParaRPr lang="en-US" sz="1500" dirty="0"/>
+          </a:p>
+          <a:p>
+            <a:pPr algn="ctr" indent="0" marL="0">
+              <a:buNone/>
+            </a:pPr>
+            <a:r>
+              <a:rPr lang="en-US" sz="1500" b="1" dirty="0">
+                <a:solidFill>
+                  <a:srgbClr val="FFFFFF"/>
+                </a:solidFill>
+                <a:latin typeface="Calibri" pitchFamily="34" charset="0"/>
+                <a:ea typeface="Calibri" pitchFamily="34" charset="-122"/>
+                <a:cs typeface="Calibri" pitchFamily="34" charset="-120"/>
+              </a:rPr>
+              <a:t>(What to do)</a:t>
+            </a:r>
+            <a:endParaRPr lang="en-US" sz="1500" dirty="0"/>
+          </a:p>
+        </p:txBody>
+      </p:sp>
+      <p:sp>
+        <p:nvSpPr>
+          <p:cNvPr id="8" name="Text 6"/>
+          <p:cNvSpPr/>
+          <p:nvPr/>
+        </p:nvSpPr>
+        <p:spPr>
+          <a:xfrm>
+            <a:off x="4701388" y="3131820"/>
+            <a:ext cx="685800" cy="914400"/>
+          </a:xfrm>
+          <a:prstGeom prst="rect">
+            <a:avLst/>
+          </a:prstGeom>
+          <a:noFill/>
+          <a:ln/>
+        </p:spPr>
+        <p:txBody>
+          <a:bodyPr wrap="square" rtlCol="0" anchor="ctr"/>
+          <a:lstStyle/>
+          <a:p>
+            <a:pPr algn="ctr" indent="0" marL="0">
+              <a:buNone/>
+            </a:pPr>
+            <a:r>
+              <a:rPr lang="en-US" sz="3400" b="1" dirty="0">
+                <a:solidFill>
+                  <a:srgbClr val="C8A84B"/>
+                </a:solidFill>
+              </a:rPr>
+              <a:t>→</a:t>
+            </a:r>
+            <a:endParaRPr lang="en-US" sz="3400" dirty="0"/>
+          </a:p>
+        </p:txBody>
+      </p:sp>
+      <p:sp>
+        <p:nvSpPr>
+          <p:cNvPr id="9" name="Shape 7"/>
+          <p:cNvSpPr/>
+          <p:nvPr/>
+        </p:nvSpPr>
+        <p:spPr>
+          <a:xfrm>
+            <a:off x="5387188" y="2880360"/>
+            <a:ext cx="1417320" cy="1417320"/>
+          </a:xfrm>
+          <a:prstGeom prst="ellipse">
+            <a:avLst/>
+          </a:prstGeom>
+          <a:solidFill>
+            <a:srgbClr val="F6F4EE"/>
+          </a:solidFill>
+          <a:ln w="63500">
             <a:solidFill>
               <a:srgbClr val="C8A84B"/>
             </a:solidFill>
             <a:prstDash val="solid"/>
           </a:ln>
-        </p:spPr>
-      </p:sp>
-      <p:sp>
-        <p:nvSpPr>
-          <p:cNvPr id="9" name="Text 7"/>
-          <p:cNvSpPr/>
-          <p:nvPr/>
-        </p:nvSpPr>
-        <p:spPr>
-          <a:xfrm>
-            <a:off x="3200400" y="1828800"/>
-            <a:ext cx="914400" cy="457200"/>
+          <a:effectLst>
+            <a:outerShdw sx="100000" sy="100000" kx="0" ky="0" algn="bl" rotWithShape="0" blurRad="177800" dist="63500" dir="2700000">
+              <a:srgbClr val="000000">
+                <a:alpha val="45000"/>
+              </a:srgbClr>
+            </a:outerShdw>
+          </a:effectLst>
+        </p:spPr>
+      </p:sp>
+      <p:sp>
+        <p:nvSpPr>
+          <p:cNvPr id="10" name="Text 8"/>
+          <p:cNvSpPr/>
+          <p:nvPr/>
+        </p:nvSpPr>
+        <p:spPr>
+          <a:xfrm>
+            <a:off x="5387188" y="2880360"/>
+            <a:ext cx="1417320" cy="1417320"/>
           </a:xfrm>
           <a:prstGeom prst="rect">
             <a:avLst/>
@@ -2280,57 +3202,100 @@
               <a:buNone/>
             </a:pPr>
             <a:r>
-              <a:rPr lang="en-US" sz="1200" b="1" dirty="0">
-                <a:solidFill>
-                  <a:srgbClr val="FFFFFF"/>
+              <a:rPr lang="en-US" sz="2400" b="1" dirty="0">
+                <a:solidFill>
+                  <a:srgbClr val="C8A84B"/>
                 </a:solidFill>
                 <a:latin typeface="Calibri" pitchFamily="34" charset="0"/>
                 <a:ea typeface="Calibri" pitchFamily="34" charset="-122"/>
                 <a:cs typeface="Calibri" pitchFamily="34" charset="-120"/>
               </a:rPr>
-              <a:t>Goal</a:t>
-            </a:r>
-            <a:endParaRPr lang="en-US" sz="1200" dirty="0"/>
-          </a:p>
-        </p:txBody>
-      </p:sp>
-      <p:sp>
-        <p:nvSpPr>
-          <p:cNvPr id="10" name="Shape 8"/>
-          <p:cNvSpPr/>
-          <p:nvPr/>
-        </p:nvSpPr>
-        <p:spPr>
-          <a:xfrm>
-            <a:off x="5577840" y="2743200"/>
-            <a:ext cx="914400" cy="457200"/>
+              <a:t>LLM</a:t>
+            </a:r>
+            <a:endParaRPr lang="en-US" sz="2400" dirty="0"/>
+          </a:p>
+        </p:txBody>
+      </p:sp>
+      <p:sp>
+        <p:nvSpPr>
+          <p:cNvPr id="11" name="Text 9"/>
+          <p:cNvSpPr/>
+          <p:nvPr/>
+        </p:nvSpPr>
+        <p:spPr>
+          <a:xfrm>
+            <a:off x="6804508" y="3131820"/>
+            <a:ext cx="685800" cy="914400"/>
+          </a:xfrm>
+          <a:prstGeom prst="rect">
+            <a:avLst/>
+          </a:prstGeom>
+          <a:noFill/>
+          <a:ln/>
+        </p:spPr>
+        <p:txBody>
+          <a:bodyPr wrap="square" rtlCol="0" anchor="ctr"/>
+          <a:lstStyle/>
+          <a:p>
+            <a:pPr algn="ctr" indent="0" marL="0">
+              <a:buNone/>
+            </a:pPr>
+            <a:r>
+              <a:rPr lang="en-US" sz="3400" b="1" dirty="0">
+                <a:solidFill>
+                  <a:srgbClr val="C8A84B"/>
+                </a:solidFill>
+              </a:rPr>
+              <a:t>→</a:t>
+            </a:r>
+            <a:endParaRPr lang="en-US" sz="3400" dirty="0"/>
+          </a:p>
+        </p:txBody>
+      </p:sp>
+      <p:sp>
+        <p:nvSpPr>
+          <p:cNvPr id="12" name="Shape 10"/>
+          <p:cNvSpPr/>
+          <p:nvPr/>
+        </p:nvSpPr>
+        <p:spPr>
+          <a:xfrm>
+            <a:off x="7490308" y="3131820"/>
+            <a:ext cx="1965960" cy="914400"/>
           </a:xfrm>
           <a:prstGeom prst="roundRect">
             <a:avLst>
-              <a:gd name="adj" fmla="val 16000"/>
+              <a:gd name="adj" fmla="val 14000"/>
             </a:avLst>
           </a:prstGeom>
           <a:solidFill>
             <a:srgbClr val="2C6B57"/>
           </a:solidFill>
-          <a:ln w="19050">
+          <a:ln w="38100">
             <a:solidFill>
               <a:srgbClr val="C8A84B"/>
             </a:solidFill>
             <a:prstDash val="solid"/>
           </a:ln>
-        </p:spPr>
-      </p:sp>
-      <p:sp>
-        <p:nvSpPr>
-          <p:cNvPr id="11" name="Text 9"/>
-          <p:cNvSpPr/>
-          <p:nvPr/>
-        </p:nvSpPr>
-        <p:spPr>
-          <a:xfrm>
-            <a:off x="5577840" y="2743200"/>
-            <a:ext cx="914400" cy="457200"/>
+          <a:effectLst>
+            <a:outerShdw sx="100000" sy="100000" kx="0" ky="0" algn="bl" rotWithShape="0" blurRad="101600" dist="38100" dir="2700000">
+              <a:srgbClr val="000000">
+                <a:alpha val="35000"/>
+              </a:srgbClr>
+            </a:outerShdw>
+          </a:effectLst>
+        </p:spPr>
+      </p:sp>
+      <p:sp>
+        <p:nvSpPr>
+          <p:cNvPr id="13" name="Text 11"/>
+          <p:cNvSpPr/>
+          <p:nvPr/>
+        </p:nvSpPr>
+        <p:spPr>
+          <a:xfrm>
+            <a:off x="7490308" y="3131820"/>
+            <a:ext cx="1965960" cy="914400"/>
           </a:xfrm>
           <a:prstGeom prst="rect">
             <a:avLst/>
@@ -2346,7 +3311,7 @@
               <a:buNone/>
             </a:pPr>
             <a:r>
-              <a:rPr lang="en-US" sz="1200" b="1" dirty="0">
+              <a:rPr lang="en-US" sz="1500" b="1" dirty="0">
                 <a:solidFill>
                   <a:srgbClr val="FFFFFF"/>
                 </a:solidFill>
@@ -2354,49 +3319,73 @@
                 <a:ea typeface="Calibri" pitchFamily="34" charset="-122"/>
                 <a:cs typeface="Calibri" pitchFamily="34" charset="-120"/>
               </a:rPr>
-              <a:t>Tools</a:t>
-            </a:r>
-            <a:endParaRPr lang="en-US" sz="1200" dirty="0"/>
-          </a:p>
-        </p:txBody>
-      </p:sp>
-      <p:sp>
-        <p:nvSpPr>
-          <p:cNvPr id="12" name="Shape 10"/>
-          <p:cNvSpPr/>
-          <p:nvPr/>
-        </p:nvSpPr>
-        <p:spPr>
-          <a:xfrm>
-            <a:off x="3200400" y="3657600"/>
-            <a:ext cx="914400" cy="457200"/>
+              <a:t>TOOLS</a:t>
+            </a:r>
+            <a:endParaRPr lang="en-US" sz="1500" dirty="0"/>
+          </a:p>
+          <a:p>
+            <a:pPr algn="ctr" indent="0" marL="0">
+              <a:buNone/>
+            </a:pPr>
+            <a:r>
+              <a:rPr lang="en-US" sz="1500" b="1" dirty="0">
+                <a:solidFill>
+                  <a:srgbClr val="FFFFFF"/>
+                </a:solidFill>
+                <a:latin typeface="Calibri" pitchFamily="34" charset="0"/>
+                <a:ea typeface="Calibri" pitchFamily="34" charset="-122"/>
+                <a:cs typeface="Calibri" pitchFamily="34" charset="-120"/>
+              </a:rPr>
+              <a:t>(How to do it)</a:t>
+            </a:r>
+            <a:endParaRPr lang="en-US" sz="1500" dirty="0"/>
+          </a:p>
+        </p:txBody>
+      </p:sp>
+      <p:sp>
+        <p:nvSpPr>
+          <p:cNvPr id="14" name="Shape 12"/>
+          <p:cNvSpPr/>
+          <p:nvPr/>
+        </p:nvSpPr>
+        <p:spPr>
+          <a:xfrm>
+            <a:off x="4907128" y="4572000"/>
+            <a:ext cx="2377440" cy="731520"/>
           </a:xfrm>
           <a:prstGeom prst="roundRect">
             <a:avLst>
-              <a:gd name="adj" fmla="val 16000"/>
+              <a:gd name="adj" fmla="val 15000"/>
             </a:avLst>
           </a:prstGeom>
           <a:solidFill>
-            <a:srgbClr val="2C6B57"/>
-          </a:solidFill>
-          <a:ln w="19050">
+            <a:srgbClr val="C8A84B"/>
+          </a:solidFill>
+          <a:ln w="12700">
             <a:solidFill>
               <a:srgbClr val="C8A84B"/>
             </a:solidFill>
             <a:prstDash val="solid"/>
           </a:ln>
-        </p:spPr>
-      </p:sp>
-      <p:sp>
-        <p:nvSpPr>
-          <p:cNvPr id="13" name="Text 11"/>
-          <p:cNvSpPr/>
-          <p:nvPr/>
-        </p:nvSpPr>
-        <p:spPr>
-          <a:xfrm>
-            <a:off x="3200400" y="3657600"/>
-            <a:ext cx="914400" cy="457200"/>
+          <a:effectLst>
+            <a:outerShdw sx="100000" sy="100000" kx="0" ky="0" algn="bl" rotWithShape="0" blurRad="101600" dist="38100" dir="2700000">
+              <a:srgbClr val="000000">
+                <a:alpha val="35000"/>
+              </a:srgbClr>
+            </a:outerShdw>
+          </a:effectLst>
+        </p:spPr>
+      </p:sp>
+      <p:sp>
+        <p:nvSpPr>
+          <p:cNvPr id="15" name="Text 13"/>
+          <p:cNvSpPr/>
+          <p:nvPr/>
+        </p:nvSpPr>
+        <p:spPr>
+          <a:xfrm>
+            <a:off x="4907128" y="4572000"/>
+            <a:ext cx="2377440" cy="731520"/>
           </a:xfrm>
           <a:prstGeom prst="rect">
             <a:avLst/>
@@ -2412,30 +3401,30 @@
               <a:buNone/>
             </a:pPr>
             <a:r>
-              <a:rPr lang="en-US" sz="1200" b="1" dirty="0">
-                <a:solidFill>
-                  <a:srgbClr val="FFFFFF"/>
+              <a:rPr lang="en-US" sz="1600" b="1" dirty="0">
+                <a:solidFill>
+                  <a:srgbClr val="1A2422"/>
                 </a:solidFill>
                 <a:latin typeface="Calibri" pitchFamily="34" charset="0"/>
                 <a:ea typeface="Calibri" pitchFamily="34" charset="-122"/>
                 <a:cs typeface="Calibri" pitchFamily="34" charset="-120"/>
               </a:rPr>
-              <a:t>Loop</a:t>
-            </a:r>
-            <a:endParaRPr lang="en-US" sz="1200" dirty="0"/>
-          </a:p>
-        </p:txBody>
-      </p:sp>
-      <p:sp>
-        <p:nvSpPr>
-          <p:cNvPr id="14" name="Text 12"/>
-          <p:cNvSpPr/>
-          <p:nvPr/>
-        </p:nvSpPr>
-        <p:spPr>
-          <a:xfrm>
-            <a:off x="274320" y="4297680"/>
-            <a:ext cx="7955280" cy="457200"/>
+              <a:t>↻  LOOP: Repeat Until Done</a:t>
+            </a:r>
+            <a:endParaRPr lang="en-US" sz="1600" dirty="0"/>
+          </a:p>
+        </p:txBody>
+      </p:sp>
+      <p:sp>
+        <p:nvSpPr>
+          <p:cNvPr id="16" name="Text 14"/>
+          <p:cNvSpPr/>
+          <p:nvPr/>
+        </p:nvSpPr>
+        <p:spPr>
+          <a:xfrm>
+            <a:off x="411480" y="5440680"/>
+            <a:ext cx="11368735" cy="320040"/>
           </a:xfrm>
           <a:prstGeom prst="rect">
             <a:avLst/>
@@ -2451,7 +3440,7 @@
               <a:buNone/>
             </a:pPr>
             <a:r>
-              <a:rPr lang="en-US" sz="1400" b="1" dirty="0">
+              <a:rPr lang="en-US" sz="1500" i="1" dirty="0">
                 <a:solidFill>
                   <a:srgbClr val="C8A84B"/>
                 </a:solidFill>
@@ -2459,26 +3448,26 @@
                 <a:ea typeface="Calibri" pitchFamily="34" charset="-122"/>
                 <a:cs typeface="Calibri" pitchFamily="34" charset="-120"/>
               </a:rPr>
-              <a:t>↻ Repeats until goal achieved</a:t>
-            </a:r>
-            <a:endParaRPr lang="en-US" sz="1400" dirty="0"/>
-          </a:p>
-        </p:txBody>
-      </p:sp>
-      <p:sp>
-        <p:nvSpPr>
-          <p:cNvPr id="15" name="Shape 13"/>
-          <p:cNvSpPr/>
-          <p:nvPr/>
-        </p:nvSpPr>
-        <p:spPr>
-          <a:xfrm>
-            <a:off x="274320" y="5303520"/>
-            <a:ext cx="7955280" cy="457200"/>
+              <a:t>Keeps checking: is the goal achieved yet?</a:t>
+            </a:r>
+            <a:endParaRPr lang="en-US" sz="1500" dirty="0"/>
+          </a:p>
+        </p:txBody>
+      </p:sp>
+      <p:sp>
+        <p:nvSpPr>
+          <p:cNvPr id="17" name="Shape 15"/>
+          <p:cNvSpPr/>
+          <p:nvPr/>
+        </p:nvSpPr>
+        <p:spPr>
+          <a:xfrm>
+            <a:off x="411480" y="5989320"/>
+            <a:ext cx="11368735" cy="566928"/>
           </a:xfrm>
           <a:prstGeom prst="roundRect">
             <a:avLst>
-              <a:gd name="adj" fmla="val 16000"/>
+              <a:gd name="adj" fmla="val 16129"/>
             </a:avLst>
           </a:prstGeom>
           <a:solidFill>
@@ -2490,18 +3479,25 @@
             </a:solidFill>
             <a:prstDash val="solid"/>
           </a:ln>
-        </p:spPr>
-      </p:sp>
-      <p:sp>
-        <p:nvSpPr>
-          <p:cNvPr id="16" name="Text 14"/>
-          <p:cNvSpPr/>
-          <p:nvPr/>
-        </p:nvSpPr>
-        <p:spPr>
-          <a:xfrm>
-            <a:off x="365760" y="5303520"/>
-            <a:ext cx="1097280" cy="457200"/>
+          <a:effectLst>
+            <a:outerShdw sx="100000" sy="100000" kx="0" ky="0" algn="bl" rotWithShape="0" blurRad="101600" dist="25400" dir="2700000">
+              <a:srgbClr val="000000">
+                <a:alpha val="35000"/>
+              </a:srgbClr>
+            </a:outerShdw>
+          </a:effectLst>
+        </p:spPr>
+      </p:sp>
+      <p:sp>
+        <p:nvSpPr>
+          <p:cNvPr id="18" name="Text 16"/>
+          <p:cNvSpPr/>
+          <p:nvPr/>
+        </p:nvSpPr>
+        <p:spPr>
+          <a:xfrm>
+            <a:off x="594360" y="5989320"/>
+            <a:ext cx="1554480" cy="566928"/>
           </a:xfrm>
           <a:prstGeom prst="rect">
             <a:avLst/>
@@ -2517,7 +3513,7 @@
               <a:buNone/>
             </a:pPr>
             <a:r>
-              <a:rPr lang="en-US" sz="1200" b="1" dirty="0">
+              <a:rPr lang="en-US" sz="1400" b="1" dirty="0">
                 <a:solidFill>
                   <a:srgbClr val="C8A84B"/>
                 </a:solidFill>
@@ -2525,22 +3521,22 @@
                 <a:ea typeface="Calibri" pitchFamily="34" charset="-122"/>
                 <a:cs typeface="Calibri" pitchFamily="34" charset="-120"/>
               </a:rPr>
-              <a:t>TAKEAWAY</a:t>
-            </a:r>
-            <a:endParaRPr lang="en-US" sz="1200" dirty="0"/>
-          </a:p>
-        </p:txBody>
-      </p:sp>
-      <p:sp>
-        <p:nvSpPr>
-          <p:cNvPr id="17" name="Text 15"/>
-          <p:cNvSpPr/>
-          <p:nvPr/>
-        </p:nvSpPr>
-        <p:spPr>
-          <a:xfrm>
-            <a:off x="1554480" y="5303520"/>
-            <a:ext cx="6675120" cy="457200"/>
+              <a:t>TAKEAWAY:</a:t>
+            </a:r>
+            <a:endParaRPr lang="en-US" sz="1400" dirty="0"/>
+          </a:p>
+        </p:txBody>
+      </p:sp>
+      <p:sp>
+        <p:nvSpPr>
+          <p:cNvPr id="19" name="Text 17"/>
+          <p:cNvSpPr/>
+          <p:nvPr/>
+        </p:nvSpPr>
+        <p:spPr>
+          <a:xfrm>
+            <a:off x="2148840" y="5989320"/>
+            <a:ext cx="9448495" cy="566928"/>
           </a:xfrm>
           <a:prstGeom prst="rect">
             <a:avLst/>
@@ -2556,7 +3552,7 @@
               <a:buNone/>
             </a:pPr>
             <a:r>
-              <a:rPr lang="en-US" sz="1100" dirty="0">
+              <a:rPr lang="en-US" sz="1300" b="1" dirty="0">
                 <a:solidFill>
                   <a:srgbClr val="FFFFFF"/>
                 </a:solidFill>
@@ -2564,9 +3560,9 @@
                 <a:ea typeface="Calibri" pitchFamily="34" charset="-122"/>
                 <a:cs typeface="Calibri" pitchFamily="34" charset="-120"/>
               </a:rPr>
-              <a:t>Agent = LLM + Loop + Tools — it keeps going until the goal is met, not just one turn.</a:t>
-            </a:r>
-            <a:endParaRPr lang="en-US" sz="1100" dirty="0"/>
+              <a:t>Agent = LLM + Loop + Tools — it keeps working toward the goal, without stopping after one turn.</a:t>
+            </a:r>
+            <a:endParaRPr lang="en-US" sz="1300" dirty="0"/>
           </a:p>
         </p:txBody>
       </p:sp>

</xml_diff>